<commit_message>
Add explicit Gemini Developer API backend for free-tier demos
</commit_message>
<xml_diff>
--- a/artifacts/scamshield-pitch.pptx
+++ b/artifacts/scamshield-pitch.pptx
@@ -2,18 +2,18 @@
 <file path=ppt/presentation.xml><?xml version="1.0" encoding="utf-8"?>
 <p:presentation xmlns:p="http://schemas.openxmlformats.org/presentationml/2006/main">
   <p:sldMasterIdLst>
-    <p:sldMasterId xmlns:r="http://schemas.openxmlformats.org/officeDocument/2006/relationships" id="2147483648" r:id="R663ff630cd864034"/>
+    <p:sldMasterId xmlns:r="http://schemas.openxmlformats.org/officeDocument/2006/relationships" id="2147483648" r:id="Rca15cf2fe5654bd0"/>
   </p:sldMasterIdLst>
   <p:notesMasterIdLst>
-    <p:notesMasterId xmlns:r="http://schemas.openxmlformats.org/officeDocument/2006/relationships" r:id="Rc12891d8e7524ef0"/>
+    <p:notesMasterId xmlns:r="http://schemas.openxmlformats.org/officeDocument/2006/relationships" r:id="R5b9a28f7c529497f"/>
   </p:notesMasterIdLst>
   <p:sldIdLst>
-    <p:sldId xmlns:r="http://schemas.openxmlformats.org/officeDocument/2006/relationships" id="256" r:id="R3a43be0587ac444b"/>
-    <p:sldId xmlns:r="http://schemas.openxmlformats.org/officeDocument/2006/relationships" id="257" r:id="R62de3687a25c42eb"/>
-    <p:sldId xmlns:r="http://schemas.openxmlformats.org/officeDocument/2006/relationships" id="258" r:id="R2af96650e8914f52"/>
-    <p:sldId xmlns:r="http://schemas.openxmlformats.org/officeDocument/2006/relationships" id="259" r:id="R2648dcfdc7054cef"/>
-    <p:sldId xmlns:r="http://schemas.openxmlformats.org/officeDocument/2006/relationships" id="260" r:id="Re15a68b0a1264c34"/>
-    <p:sldId xmlns:r="http://schemas.openxmlformats.org/officeDocument/2006/relationships" id="261" r:id="R183093ec830e4f50"/>
+    <p:sldId xmlns:r="http://schemas.openxmlformats.org/officeDocument/2006/relationships" id="256" r:id="R8ce4280b9a884fa5"/>
+    <p:sldId xmlns:r="http://schemas.openxmlformats.org/officeDocument/2006/relationships" id="257" r:id="Re32399a0fd4d4cb3"/>
+    <p:sldId xmlns:r="http://schemas.openxmlformats.org/officeDocument/2006/relationships" id="258" r:id="R17f1ab581bd04f6a"/>
+    <p:sldId xmlns:r="http://schemas.openxmlformats.org/officeDocument/2006/relationships" id="259" r:id="Rc8685eb0a5824947"/>
+    <p:sldId xmlns:r="http://schemas.openxmlformats.org/officeDocument/2006/relationships" id="260" r:id="R5ce6d1504498423d"/>
+    <p:sldId xmlns:r="http://schemas.openxmlformats.org/officeDocument/2006/relationships" id="261" r:id="R23510dfc8d224be0"/>
   </p:sldIdLst>
   <p:sldSz cx="12192000" cy="6858000"/>
   <p:notesSz cx="6858000" cy="9144000"/>
@@ -657,7 +657,7 @@
           <a:lstStyle xmlns:a="http://schemas.openxmlformats.org/drawingml/2006/main"/>
           <a:p xmlns:a="http://schemas.openxmlformats.org/drawingml/2006/main">
             <a:r>
-              <a:t>Context classification is configurable: Jev or Gemini on Vertex AI. Gemini explanation remains a separate call after the recommendation is stored. Fixture mode supports a reproducible offline demonstration. Live providers and deployment are unverified. Source: approved design specification, sections “Architecture” and “Model boundaries and resilience”, with the project integration clarification that Google Cloud Gemini classification is supported and Jev is optional.</a:t>
+              <a:t>The live classifier can use Gemini Developer API by configuration; Vertex AI remains optional. Gemini explanation is a separate, optional operation after the recommendation is stored. The hackathon path is a local app with SQLite and the Gemini Developer API free tier. Cloud Run and Vertex AI are optional extensions; usage can incur charges. Default remains fixture mode, live calls are unverified, and no paid services are provisioned. Google’s current pricing documentation lists free input and output for standard Gemini 2.5 Flash and Flash-Lite, subject to rate limits, and says free-tier content may be used to improve Google products. Use synthetic data with the free tier. Source: https://ai.google.dev/gemini-api/docs/pricing; approved design specification, sections “Architecture” and “Model boundaries and resilience”; current project integration configuration.</a:t>
             </a:r>
           </a:p>
         </p:txBody>
@@ -797,7 +797,7 @@
           <a:lstStyle xmlns:a="http://schemas.openxmlformats.org/drawingml/2006/main"/>
           <a:p xmlns:a="http://schemas.openxmlformats.org/drawingml/2006/main">
             <a:r>
-              <a:t>The schedule is a proposed delivery sequence, not a claim that implementation or deployment has completed. Cloud readiness requires integration checks against PostgreSQL and end-to-end flows. Optional invoice extraction is outside this first pitch scope. Source: approved design specification “Delivery sequence” and implementation plan “Presentation”.</a:t>
+              <a:t>The schedule is a proposed delivery sequence, not a claim that implementation or deployment has completed. The local hackathon path uses SQLite and Gemini Developer API. Free tier availability is subject to rate limits and data-use terms; Google’s current documentation says free-tier content may be used to improve products, so use synthetic inputs. Vertex AI and Cloud Run are optional extensions and can incur charges. No paid services have been provisioned. Source: https://ai.google.dev/gemini-api/docs/pricing; approved design specification “Delivery sequence” and implementation plan “Presentation”.</a:t>
             </a:r>
           </a:p>
         </p:txBody>
@@ -844,7 +844,7 @@
           <p:cNvPr id="3" name="Title">
             <a:extLst xmlns:a="http://schemas.openxmlformats.org/drawingml/2006/main">
               <a:ext uri="{FF2B5EF4-FFF2-40B4-BE49-F238E27FC236}">
-                <a16:creationId xmlns:a16="http://schemas.microsoft.com/office/drawing/2014/main" id="{11FCC3D2-221B-4A79-9071-97D8B8E10315}"/>
+                <a16:creationId xmlns:a16="http://schemas.microsoft.com/office/drawing/2014/main" id="{74B4AD26-03E4-4F84-B8E2-882EF03D9710}"/>
               </a:ext>
             </a:extLst>
           </p:cNvPr>
@@ -1001,7 +1001,7 @@
           <p:cNvPr id="2" name="Subtitle">
             <a:extLst xmlns:a="http://schemas.openxmlformats.org/drawingml/2006/main">
               <a:ext uri="{FF2B5EF4-FFF2-40B4-BE49-F238E27FC236}">
-                <a16:creationId xmlns:a16="http://schemas.microsoft.com/office/drawing/2014/main" id="{890781E0-6B5D-4F3C-9316-D430AFE7235A}"/>
+                <a16:creationId xmlns:a16="http://schemas.microsoft.com/office/drawing/2014/main" id="{9BD27E04-02EB-45A7-A014-9D2E0DA0732E}"/>
               </a:ext>
             </a:extLst>
           </p:cNvPr>
@@ -1175,7 +1175,7 @@
           <p:cNvPr id="2" name="Section title">
             <a:extLst xmlns:a="http://schemas.openxmlformats.org/drawingml/2006/main">
               <a:ext uri="{FF2B5EF4-FFF2-40B4-BE49-F238E27FC236}">
-                <a16:creationId xmlns:a16="http://schemas.microsoft.com/office/drawing/2014/main" id="{0A5F19F3-0EB2-4062-BFAE-80EED2D7F5B9}"/>
+                <a16:creationId xmlns:a16="http://schemas.microsoft.com/office/drawing/2014/main" id="{81E7B024-710E-4CF9-843B-744015BBD05B}"/>
               </a:ext>
             </a:extLst>
           </p:cNvPr>
@@ -1349,7 +1349,7 @@
           <p:cNvPr id="3" name="Title">
             <a:extLst xmlns:a="http://schemas.openxmlformats.org/drawingml/2006/main">
               <a:ext uri="{FF2B5EF4-FFF2-40B4-BE49-F238E27FC236}">
-                <a16:creationId xmlns:a16="http://schemas.microsoft.com/office/drawing/2014/main" id="{1D61F080-F56B-4705-BFE9-FC27613526CE}"/>
+                <a16:creationId xmlns:a16="http://schemas.microsoft.com/office/drawing/2014/main" id="{469F312D-54AB-4D25-A9C1-272066185593}"/>
               </a:ext>
             </a:extLst>
           </p:cNvPr>
@@ -1506,7 +1506,7 @@
           <p:cNvPr id="2" name="Body">
             <a:extLst xmlns:a="http://schemas.openxmlformats.org/drawingml/2006/main">
               <a:ext uri="{FF2B5EF4-FFF2-40B4-BE49-F238E27FC236}">
-                <a16:creationId xmlns:a16="http://schemas.microsoft.com/office/drawing/2014/main" id="{A0429F6C-8F71-4998-B351-2DB3C0B1C948}"/>
+                <a16:creationId xmlns:a16="http://schemas.microsoft.com/office/drawing/2014/main" id="{54C264E7-91E4-490D-993E-BA41C1D50411}"/>
               </a:ext>
             </a:extLst>
           </p:cNvPr>
@@ -1680,7 +1680,7 @@
           <p:cNvPr id="4" name="Title">
             <a:extLst xmlns:a="http://schemas.openxmlformats.org/drawingml/2006/main">
               <a:ext uri="{FF2B5EF4-FFF2-40B4-BE49-F238E27FC236}">
-                <a16:creationId xmlns:a16="http://schemas.microsoft.com/office/drawing/2014/main" id="{E1F5A207-BF20-4AFD-8873-0221B650E611}"/>
+                <a16:creationId xmlns:a16="http://schemas.microsoft.com/office/drawing/2014/main" id="{9F930F87-FBD7-4189-907F-37D134C9EC46}"/>
               </a:ext>
             </a:extLst>
           </p:cNvPr>
@@ -1837,7 +1837,7 @@
           <p:cNvPr id="2" name="Left column">
             <a:extLst xmlns:a="http://schemas.openxmlformats.org/drawingml/2006/main">
               <a:ext uri="{FF2B5EF4-FFF2-40B4-BE49-F238E27FC236}">
-                <a16:creationId xmlns:a16="http://schemas.microsoft.com/office/drawing/2014/main" id="{7B5E8636-34C1-402D-B5AE-FC4450880904}"/>
+                <a16:creationId xmlns:a16="http://schemas.microsoft.com/office/drawing/2014/main" id="{7A5FD7BC-31ED-4557-96EF-514A3F08BCE4}"/>
               </a:ext>
             </a:extLst>
           </p:cNvPr>
@@ -1994,7 +1994,7 @@
           <p:cNvPr id="3" name="Right column">
             <a:extLst xmlns:a="http://schemas.openxmlformats.org/drawingml/2006/main">
               <a:ext uri="{FF2B5EF4-FFF2-40B4-BE49-F238E27FC236}">
-                <a16:creationId xmlns:a16="http://schemas.microsoft.com/office/drawing/2014/main" id="{3483D2E1-FE49-4D63-B24E-FD49147A29AD}"/>
+                <a16:creationId xmlns:a16="http://schemas.microsoft.com/office/drawing/2014/main" id="{73D9370F-B993-4DD8-B169-24ACBE3AF4EC}"/>
               </a:ext>
             </a:extLst>
           </p:cNvPr>
@@ -2168,7 +2168,7 @@
           <p:cNvPr id="3" name="Title">
             <a:extLst xmlns:a="http://schemas.openxmlformats.org/drawingml/2006/main">
               <a:ext uri="{FF2B5EF4-FFF2-40B4-BE49-F238E27FC236}">
-                <a16:creationId xmlns:a16="http://schemas.microsoft.com/office/drawing/2014/main" id="{92154D8D-E573-4474-AFB5-6A425EE87F5C}"/>
+                <a16:creationId xmlns:a16="http://schemas.microsoft.com/office/drawing/2014/main" id="{96289BB2-AF49-4F79-87D6-39CA9F49BAFB}"/>
               </a:ext>
             </a:extLst>
           </p:cNvPr>
@@ -2325,7 +2325,7 @@
           <p:cNvPr id="2" name="Left column">
             <a:extLst xmlns:a="http://schemas.openxmlformats.org/drawingml/2006/main">
               <a:ext uri="{FF2B5EF4-FFF2-40B4-BE49-F238E27FC236}">
-                <a16:creationId xmlns:a16="http://schemas.microsoft.com/office/drawing/2014/main" id="{C38E5DFC-6953-4B97-9E6A-29C0CA8E0C32}"/>
+                <a16:creationId xmlns:a16="http://schemas.microsoft.com/office/drawing/2014/main" id="{FEF9F643-420B-420A-A39A-526CCB75EFDD}"/>
               </a:ext>
             </a:extLst>
           </p:cNvPr>
@@ -2520,12 +2520,12 @@
   </p:cSld>
   <p:clrMap bg1="lt1" tx1="dk1" bg2="lt2" tx2="dk2" accent1="accent1" accent2="accent2" accent3="accent3" accent4="accent4" accent5="accent5" accent6="accent6" hlink="hlink" folHlink="folHlink"/>
   <p:sldLayoutIdLst>
-    <p:sldLayoutId xmlns:r="http://schemas.openxmlformats.org/officeDocument/2006/relationships" id="2147483649" r:id="R4d2f3976bd844511"/>
-    <p:sldLayoutId xmlns:r="http://schemas.openxmlformats.org/officeDocument/2006/relationships" id="2147483650" r:id="R0876175923e24faa"/>
-    <p:sldLayoutId xmlns:r="http://schemas.openxmlformats.org/officeDocument/2006/relationships" id="2147483651" r:id="R051b01d998714a34"/>
-    <p:sldLayoutId xmlns:r="http://schemas.openxmlformats.org/officeDocument/2006/relationships" id="2147483652" r:id="R79a8e2abf05a446e"/>
-    <p:sldLayoutId xmlns:r="http://schemas.openxmlformats.org/officeDocument/2006/relationships" id="2147483653" r:id="R3c293a8d0740495d"/>
-    <p:sldLayoutId xmlns:r="http://schemas.openxmlformats.org/officeDocument/2006/relationships" id="2147483654" r:id="R4267ce4243f344fd"/>
+    <p:sldLayoutId xmlns:r="http://schemas.openxmlformats.org/officeDocument/2006/relationships" id="2147483649" r:id="R657b4af440fd43c8"/>
+    <p:sldLayoutId xmlns:r="http://schemas.openxmlformats.org/officeDocument/2006/relationships" id="2147483650" r:id="Ra8ad9e94111849a0"/>
+    <p:sldLayoutId xmlns:r="http://schemas.openxmlformats.org/officeDocument/2006/relationships" id="2147483651" r:id="Rd1b21f8f3ed2459c"/>
+    <p:sldLayoutId xmlns:r="http://schemas.openxmlformats.org/officeDocument/2006/relationships" id="2147483652" r:id="Rab9550d6a36943c2"/>
+    <p:sldLayoutId xmlns:r="http://schemas.openxmlformats.org/officeDocument/2006/relationships" id="2147483653" r:id="R3cb7ce4d5c364fa1"/>
+    <p:sldLayoutId xmlns:r="http://schemas.openxmlformats.org/officeDocument/2006/relationships" id="2147483654" r:id="R9d205a240e6f4603"/>
   </p:sldLayoutIdLst>
   <p:txStyles>
     <p:titleStyle>
@@ -3076,7 +3076,7 @@
           <p:cNvPr id="13" name="SCAMSHIELD">
             <a:extLst xmlns:a="http://schemas.openxmlformats.org/drawingml/2006/main">
               <a:ext uri="{FF2B5EF4-FFF2-40B4-BE49-F238E27FC236}">
-                <a16:creationId xmlns:a16="http://schemas.microsoft.com/office/drawing/2014/main" id="{63FF1C7B-8378-4D84-B9F8-B1AFEB0BF1F1}"/>
+                <a16:creationId xmlns:a16="http://schemas.microsoft.com/office/drawing/2014/main" id="{777F96A8-B0A9-4B0F-8944-ED034E870E63}"/>
               </a:ext>
             </a:extLst>
           </p:cNvPr>
@@ -3149,7 +3149,7 @@
           <p:cNvPr id="2" name="PAYMENT SAFETY  /  CONCEPT">
             <a:extLst xmlns:a="http://schemas.openxmlformats.org/drawingml/2006/main">
               <a:ext uri="{FF2B5EF4-FFF2-40B4-BE49-F238E27FC236}">
-                <a16:creationId xmlns:a16="http://schemas.microsoft.com/office/drawing/2014/main" id="{E96FCEB4-464D-4C0F-978C-0B4A9B76C1B9}"/>
+                <a16:creationId xmlns:a16="http://schemas.microsoft.com/office/drawing/2014/main" id="{708E1FE2-F21A-4E21-8334-559074ABF2F6}"/>
               </a:ext>
             </a:extLst>
           </p:cNvPr>
@@ -3222,7 +3222,7 @@
           <p:cNvPr id="3" name="">
             <a:extLst xmlns:a="http://schemas.openxmlformats.org/drawingml/2006/main">
               <a:ext uri="{FF2B5EF4-FFF2-40B4-BE49-F238E27FC236}">
-                <a16:creationId xmlns:a16="http://schemas.microsoft.com/office/drawing/2014/main" id="{5224EBFA-CE6E-4DF6-B426-91611F0E6661}"/>
+                <a16:creationId xmlns:a16="http://schemas.microsoft.com/office/drawing/2014/main" id="{45BD6BEB-4F45-402F-B898-A2005D6113E1}"/>
               </a:ext>
             </a:extLst>
           </p:cNvPr>
@@ -3253,7 +3253,7 @@
           <p:cNvPr id="4" name="A pause at the&#10;right moment.">
             <a:extLst xmlns:a="http://schemas.openxmlformats.org/drawingml/2006/main">
               <a:ext uri="{FF2B5EF4-FFF2-40B4-BE49-F238E27FC236}">
-                <a16:creationId xmlns:a16="http://schemas.microsoft.com/office/drawing/2014/main" id="{AF3A4D3C-676B-4C21-8448-21CE1F4034AA}"/>
+                <a16:creationId xmlns:a16="http://schemas.microsoft.com/office/drawing/2014/main" id="{1AE1DD4B-F6C0-43B8-AC7A-E0AB4DBF6195}"/>
               </a:ext>
             </a:extLst>
           </p:cNvPr>
@@ -3353,7 +3353,7 @@
           <p:cNvPr id="5" name="Payment risk review for the details that">
             <a:extLst xmlns:a="http://schemas.openxmlformats.org/drawingml/2006/main">
               <a:ext uri="{FF2B5EF4-FFF2-40B4-BE49-F238E27FC236}">
-                <a16:creationId xmlns:a16="http://schemas.microsoft.com/office/drawing/2014/main" id="{E966FA31-DFCD-42E0-8D6D-DFF3B342683A}"/>
+                <a16:creationId xmlns:a16="http://schemas.microsoft.com/office/drawing/2014/main" id="{7E8F26A7-3361-4352-8AD4-63CEEF5C8F94}"/>
               </a:ext>
             </a:extLst>
           </p:cNvPr>
@@ -3453,7 +3453,7 @@
           <p:cNvPr id="6" name="">
             <a:extLst xmlns:a="http://schemas.openxmlformats.org/drawingml/2006/main">
               <a:ext uri="{FF2B5EF4-FFF2-40B4-BE49-F238E27FC236}">
-                <a16:creationId xmlns:a16="http://schemas.microsoft.com/office/drawing/2014/main" id="{B1080F7C-5C73-42C3-A6A0-71594CFEF8DC}"/>
+                <a16:creationId xmlns:a16="http://schemas.microsoft.com/office/drawing/2014/main" id="{44C51CA1-29DA-4DA1-95FB-023D30D7FA5D}"/>
               </a:ext>
             </a:extLst>
           </p:cNvPr>
@@ -3484,7 +3484,7 @@
           <p:cNvPr id="7" name="ONE ASSESSMENT ENGINE">
             <a:extLst xmlns:a="http://schemas.openxmlformats.org/drawingml/2006/main">
               <a:ext uri="{FF2B5EF4-FFF2-40B4-BE49-F238E27FC236}">
-                <a16:creationId xmlns:a16="http://schemas.microsoft.com/office/drawing/2014/main" id="{DD1E6A9B-E55D-4990-80D9-91410A5B9101}"/>
+                <a16:creationId xmlns:a16="http://schemas.microsoft.com/office/drawing/2014/main" id="{8829E328-A6B1-4181-A5E7-DF1A4C32E2F5}"/>
               </a:ext>
             </a:extLst>
           </p:cNvPr>
@@ -3557,7 +3557,7 @@
           <p:cNvPr id="8" name="Consumer transfer">
             <a:extLst xmlns:a="http://schemas.openxmlformats.org/drawingml/2006/main">
               <a:ext uri="{FF2B5EF4-FFF2-40B4-BE49-F238E27FC236}">
-                <a16:creationId xmlns:a16="http://schemas.microsoft.com/office/drawing/2014/main" id="{EE33F85A-30EA-43CE-A548-A8E5B44EBD42}"/>
+                <a16:creationId xmlns:a16="http://schemas.microsoft.com/office/drawing/2014/main" id="{644074A9-40C2-4728-AB10-2D1F66656B06}"/>
               </a:ext>
             </a:extLst>
           </p:cNvPr>
@@ -3630,7 +3630,7 @@
           <p:cNvPr id="9" name="UPI payment with message context">
             <a:extLst xmlns:a="http://schemas.openxmlformats.org/drawingml/2006/main">
               <a:ext uri="{FF2B5EF4-FFF2-40B4-BE49-F238E27FC236}">
-                <a16:creationId xmlns:a16="http://schemas.microsoft.com/office/drawing/2014/main" id="{2392A005-45C6-4738-9207-2F0D0C792782}"/>
+                <a16:creationId xmlns:a16="http://schemas.microsoft.com/office/drawing/2014/main" id="{1F5A2D2E-FBBD-4DD3-95BB-1E8353C4CD68}"/>
               </a:ext>
             </a:extLst>
           </p:cNvPr>
@@ -3703,7 +3703,7 @@
           <p:cNvPr id="10" name="Business invoice">
             <a:extLst xmlns:a="http://schemas.openxmlformats.org/drawingml/2006/main">
               <a:ext uri="{FF2B5EF4-FFF2-40B4-BE49-F238E27FC236}">
-                <a16:creationId xmlns:a16="http://schemas.microsoft.com/office/drawing/2014/main" id="{9B9FD9A5-0ACC-4A68-8D5A-799D7A012E09}"/>
+                <a16:creationId xmlns:a16="http://schemas.microsoft.com/office/drawing/2014/main" id="{5632BA21-4326-485E-B9D6-B5F0B75536A7}"/>
               </a:ext>
             </a:extLst>
           </p:cNvPr>
@@ -3776,7 +3776,7 @@
           <p:cNvPr id="11" name="Vendor details checked against records">
             <a:extLst xmlns:a="http://schemas.openxmlformats.org/drawingml/2006/main">
               <a:ext uri="{FF2B5EF4-FFF2-40B4-BE49-F238E27FC236}">
-                <a16:creationId xmlns:a16="http://schemas.microsoft.com/office/drawing/2014/main" id="{85C9128D-0F40-4C72-B034-E83E285B9890}"/>
+                <a16:creationId xmlns:a16="http://schemas.microsoft.com/office/drawing/2014/main" id="{2090736E-C87C-4C1E-992A-B7BD569087A9}"/>
               </a:ext>
             </a:extLst>
           </p:cNvPr>
@@ -3849,7 +3849,7 @@
           <p:cNvPr id="12" name="01">
             <a:extLst xmlns:a="http://schemas.openxmlformats.org/drawingml/2006/main">
               <a:ext uri="{FF2B5EF4-FFF2-40B4-BE49-F238E27FC236}">
-                <a16:creationId xmlns:a16="http://schemas.microsoft.com/office/drawing/2014/main" id="{610CA576-3B9A-42BD-9456-A5420738B8F0}"/>
+                <a16:creationId xmlns:a16="http://schemas.microsoft.com/office/drawing/2014/main" id="{D2381C86-08A7-405E-A7DB-E92C1E14AEE9}"/>
               </a:ext>
             </a:extLst>
           </p:cNvPr>
@@ -3920,7 +3920,7 @@
     </p:spTree>
     <p:extLst>
       <p:ext uri="{BB962C8B-B14F-4D97-AF65-F5344CB8AC3E}">
-        <p14:creationId xmlns:p14="http://schemas.microsoft.com/office/powerpoint/2010/main" val="1304325513"/>
+        <p14:creationId xmlns:p14="http://schemas.microsoft.com/office/powerpoint/2010/main" val="1533867524"/>
       </p:ext>
     </p:extLst>
   </p:cSld>
@@ -3951,7 +3951,7 @@
           <p:cNvPr id="20" name="SCAMSHIELD  /  CONCEPT PITCH">
             <a:extLst xmlns:a="http://schemas.openxmlformats.org/drawingml/2006/main">
               <a:ext uri="{FF2B5EF4-FFF2-40B4-BE49-F238E27FC236}">
-                <a16:creationId xmlns:a16="http://schemas.microsoft.com/office/drawing/2014/main" id="{4CD6C99F-AEC3-481B-8EEF-6D34109A4733}"/>
+                <a16:creationId xmlns:a16="http://schemas.microsoft.com/office/drawing/2014/main" id="{AF5C7156-AA45-43C6-B3B9-83F88EA8F81D}"/>
               </a:ext>
             </a:extLst>
           </p:cNvPr>
@@ -4024,7 +4024,7 @@
           <p:cNvPr id="2" name="02  /  06">
             <a:extLst xmlns:a="http://schemas.openxmlformats.org/drawingml/2006/main">
               <a:ext uri="{FF2B5EF4-FFF2-40B4-BE49-F238E27FC236}">
-                <a16:creationId xmlns:a16="http://schemas.microsoft.com/office/drawing/2014/main" id="{27335B55-0591-4F7A-B2E8-E346B89EA2CA}"/>
+                <a16:creationId xmlns:a16="http://schemas.microsoft.com/office/drawing/2014/main" id="{F6E9515B-17D1-4023-BACF-CB788B37629A}"/>
               </a:ext>
             </a:extLst>
           </p:cNvPr>
@@ -4097,7 +4097,7 @@
           <p:cNvPr id="3" name="">
             <a:extLst xmlns:a="http://schemas.openxmlformats.org/drawingml/2006/main">
               <a:ext uri="{FF2B5EF4-FFF2-40B4-BE49-F238E27FC236}">
-                <a16:creationId xmlns:a16="http://schemas.microsoft.com/office/drawing/2014/main" id="{8D5111EB-2920-42AD-9B1A-C71541C2D3CB}"/>
+                <a16:creationId xmlns:a16="http://schemas.microsoft.com/office/drawing/2014/main" id="{B02621B9-68DE-4133-BCFC-BAE828C47963}"/>
               </a:ext>
             </a:extLst>
           </p:cNvPr>
@@ -4128,7 +4128,7 @@
           <p:cNvPr id="4" name="The risky detail often arrives beside th">
             <a:extLst xmlns:a="http://schemas.openxmlformats.org/drawingml/2006/main">
               <a:ext uri="{FF2B5EF4-FFF2-40B4-BE49-F238E27FC236}">
-                <a16:creationId xmlns:a16="http://schemas.microsoft.com/office/drawing/2014/main" id="{F65432CF-506F-4BD4-9CE1-F51DE012C190}"/>
+                <a16:creationId xmlns:a16="http://schemas.microsoft.com/office/drawing/2014/main" id="{2F0A054D-870F-4A1E-90FF-1DC2AB6AB686}"/>
               </a:ext>
             </a:extLst>
           </p:cNvPr>
@@ -4201,7 +4201,7 @@
           <p:cNvPr id="5" name="Forms capture amount and destination. Co">
             <a:extLst xmlns:a="http://schemas.openxmlformats.org/drawingml/2006/main">
               <a:ext uri="{FF2B5EF4-FFF2-40B4-BE49-F238E27FC236}">
-                <a16:creationId xmlns:a16="http://schemas.microsoft.com/office/drawing/2014/main" id="{76B8A8F9-DC5E-46E7-8C6E-2490B18BD34F}"/>
+                <a16:creationId xmlns:a16="http://schemas.microsoft.com/office/drawing/2014/main" id="{3EA68F19-406A-4D3B-A1BA-050AEDD8FC50}"/>
               </a:ext>
             </a:extLst>
           </p:cNvPr>
@@ -4274,7 +4274,7 @@
           <p:cNvPr id="6" name="SYNTHETIC EXAMPLE  /  UPI TRANSFER">
             <a:extLst xmlns:a="http://schemas.openxmlformats.org/drawingml/2006/main">
               <a:ext uri="{FF2B5EF4-FFF2-40B4-BE49-F238E27FC236}">
-                <a16:creationId xmlns:a16="http://schemas.microsoft.com/office/drawing/2014/main" id="{EA61A833-2FAF-4022-AFF8-8E35A8A922FF}"/>
+                <a16:creationId xmlns:a16="http://schemas.microsoft.com/office/drawing/2014/main" id="{06837E78-5CC8-4766-B592-15DA03FA326A}"/>
               </a:ext>
             </a:extLst>
           </p:cNvPr>
@@ -4347,7 +4347,7 @@
           <p:cNvPr id="7" name="₹25,000">
             <a:extLst xmlns:a="http://schemas.openxmlformats.org/drawingml/2006/main">
               <a:ext uri="{FF2B5EF4-FFF2-40B4-BE49-F238E27FC236}">
-                <a16:creationId xmlns:a16="http://schemas.microsoft.com/office/drawing/2014/main" id="{D67B8003-4DA5-4E82-A065-15C8687E4275}"/>
+                <a16:creationId xmlns:a16="http://schemas.microsoft.com/office/drawing/2014/main" id="{03CF7101-0DCA-4F3C-A31B-0CD603F9608B}"/>
               </a:ext>
             </a:extLst>
           </p:cNvPr>
@@ -4420,7 +4420,7 @@
           <p:cNvPr id="8" name="New recipient  ·  reserve@upi">
             <a:extLst xmlns:a="http://schemas.openxmlformats.org/drawingml/2006/main">
               <a:ext uri="{FF2B5EF4-FFF2-40B4-BE49-F238E27FC236}">
-                <a16:creationId xmlns:a16="http://schemas.microsoft.com/office/drawing/2014/main" id="{3C3E1F14-B721-4659-83B2-AA23366D372C}"/>
+                <a16:creationId xmlns:a16="http://schemas.microsoft.com/office/drawing/2014/main" id="{62B6C112-85D4-42A0-8213-B1BD166C935F}"/>
               </a:ext>
             </a:extLst>
           </p:cNvPr>
@@ -4493,7 +4493,7 @@
           <p:cNvPr id="9" name="">
             <a:extLst xmlns:a="http://schemas.openxmlformats.org/drawingml/2006/main">
               <a:ext uri="{FF2B5EF4-FFF2-40B4-BE49-F238E27FC236}">
-                <a16:creationId xmlns:a16="http://schemas.microsoft.com/office/drawing/2014/main" id="{B2C5615B-6054-44BE-A22D-8F610E57DDD1}"/>
+                <a16:creationId xmlns:a16="http://schemas.microsoft.com/office/drawing/2014/main" id="{FC29F43C-8A2D-49F4-9686-07655726DAF5}"/>
               </a:ext>
             </a:extLst>
           </p:cNvPr>
@@ -4524,7 +4524,7 @@
           <p:cNvPr id="10" name="“Move your money to a safe account now.&#10;">
             <a:extLst xmlns:a="http://schemas.openxmlformats.org/drawingml/2006/main">
               <a:ext uri="{FF2B5EF4-FFF2-40B4-BE49-F238E27FC236}">
-                <a16:creationId xmlns:a16="http://schemas.microsoft.com/office/drawing/2014/main" id="{BC6B6A6E-D48B-4434-8AE7-3D1B05CB6E32}"/>
+                <a16:creationId xmlns:a16="http://schemas.microsoft.com/office/drawing/2014/main" id="{19920273-9774-486D-9C14-5A637F5CDEDD}"/>
               </a:ext>
             </a:extLst>
           </p:cNvPr>
@@ -4624,7 +4624,7 @@
           <p:cNvPr id="11" name="MESSAGE TEXT IS EVIDENCE, NOT AN INSTRUC">
             <a:extLst xmlns:a="http://schemas.openxmlformats.org/drawingml/2006/main">
               <a:ext uri="{FF2B5EF4-FFF2-40B4-BE49-F238E27FC236}">
-                <a16:creationId xmlns:a16="http://schemas.microsoft.com/office/drawing/2014/main" id="{B75AF692-C881-4EFD-B068-EB46C2012069}"/>
+                <a16:creationId xmlns:a16="http://schemas.microsoft.com/office/drawing/2014/main" id="{C28AC8E0-3E2D-4226-AC5E-F0C757D58600}"/>
               </a:ext>
             </a:extLst>
           </p:cNvPr>
@@ -4697,7 +4697,7 @@
           <p:cNvPr id="12" name="">
             <a:extLst xmlns:a="http://schemas.openxmlformats.org/drawingml/2006/main">
               <a:ext uri="{FF2B5EF4-FFF2-40B4-BE49-F238E27FC236}">
-                <a16:creationId xmlns:a16="http://schemas.microsoft.com/office/drawing/2014/main" id="{26639F70-FA8B-4F2F-BAEC-9AA27CCD7EA4}"/>
+                <a16:creationId xmlns:a16="http://schemas.microsoft.com/office/drawing/2014/main" id="{B8B0321A-E541-4E74-89E0-3F80315743A1}"/>
               </a:ext>
             </a:extLst>
           </p:cNvPr>
@@ -4725,7 +4725,7 @@
           <p:cNvPr id="13" name="WHAT THE REVIEW CAN SAY">
             <a:extLst xmlns:a="http://schemas.openxmlformats.org/drawingml/2006/main">
               <a:ext uri="{FF2B5EF4-FFF2-40B4-BE49-F238E27FC236}">
-                <a16:creationId xmlns:a16="http://schemas.microsoft.com/office/drawing/2014/main" id="{FD251A3F-C1DE-49F5-99A2-AEBAE0BCD841}"/>
+                <a16:creationId xmlns:a16="http://schemas.microsoft.com/office/drawing/2014/main" id="{7F976109-A34D-4841-96BA-00824CC0F738}"/>
               </a:ext>
             </a:extLst>
           </p:cNvPr>
@@ -4798,7 +4798,7 @@
           <p:cNvPr id="14" name="Review the request&#10;before proceeding.">
             <a:extLst xmlns:a="http://schemas.openxmlformats.org/drawingml/2006/main">
               <a:ext uri="{FF2B5EF4-FFF2-40B4-BE49-F238E27FC236}">
-                <a16:creationId xmlns:a16="http://schemas.microsoft.com/office/drawing/2014/main" id="{99E38C9A-3B08-415E-B32F-B328E9B82289}"/>
+                <a16:creationId xmlns:a16="http://schemas.microsoft.com/office/drawing/2014/main" id="{734BDDB8-0769-43E7-AE9F-389F2522DDF9}"/>
               </a:ext>
             </a:extLst>
           </p:cNvPr>
@@ -4898,7 +4898,7 @@
           <p:cNvPr id="15" name="Recorded signals">
             <a:extLst xmlns:a="http://schemas.openxmlformats.org/drawingml/2006/main">
               <a:ext uri="{FF2B5EF4-FFF2-40B4-BE49-F238E27FC236}">
-                <a16:creationId xmlns:a16="http://schemas.microsoft.com/office/drawing/2014/main" id="{C08BF4F2-BFC5-4B43-B543-16994D3E7EFA}"/>
+                <a16:creationId xmlns:a16="http://schemas.microsoft.com/office/drawing/2014/main" id="{6EE2F340-4696-4EC7-8B6C-92F052D2F809}"/>
               </a:ext>
             </a:extLst>
           </p:cNvPr>
@@ -4971,7 +4971,7 @@
           <p:cNvPr id="16" name="New recipient&#10;Safe-account language&#10;Requ">
             <a:extLst xmlns:a="http://schemas.openxmlformats.org/drawingml/2006/main">
               <a:ext uri="{FF2B5EF4-FFF2-40B4-BE49-F238E27FC236}">
-                <a16:creationId xmlns:a16="http://schemas.microsoft.com/office/drawing/2014/main" id="{204E8CF5-7592-4BC8-AAC7-1A500715F1CC}"/>
+                <a16:creationId xmlns:a16="http://schemas.microsoft.com/office/drawing/2014/main" id="{03A46B3E-5C6F-4D8E-984B-C7CD5B69A49B}"/>
               </a:ext>
             </a:extLst>
           </p:cNvPr>
@@ -5098,7 +5098,7 @@
           <p:cNvPr id="17" name="A recommendation follows configured poli">
             <a:extLst xmlns:a="http://schemas.openxmlformats.org/drawingml/2006/main">
               <a:ext uri="{FF2B5EF4-FFF2-40B4-BE49-F238E27FC236}">
-                <a16:creationId xmlns:a16="http://schemas.microsoft.com/office/drawing/2014/main" id="{1A7F23DD-64FC-4DAC-AE52-8BCEF832EAA3}"/>
+                <a16:creationId xmlns:a16="http://schemas.microsoft.com/office/drawing/2014/main" id="{D9730E84-B4F2-4C88-878B-022F84D5E4C9}"/>
               </a:ext>
             </a:extLst>
           </p:cNvPr>
@@ -5171,7 +5171,7 @@
           <p:cNvPr id="18" name="">
             <a:extLst xmlns:a="http://schemas.openxmlformats.org/drawingml/2006/main">
               <a:ext uri="{FF2B5EF4-FFF2-40B4-BE49-F238E27FC236}">
-                <a16:creationId xmlns:a16="http://schemas.microsoft.com/office/drawing/2014/main" id="{D26EC457-91EC-4E19-BBBA-2E8E84007224}"/>
+                <a16:creationId xmlns:a16="http://schemas.microsoft.com/office/drawing/2014/main" id="{AFA21D0C-E83F-4583-89C8-687D103B50BC}"/>
               </a:ext>
             </a:extLst>
           </p:cNvPr>
@@ -5202,7 +5202,7 @@
           <p:cNvPr id="19" name="Synthetic demonstration concept  /  No p">
             <a:extLst xmlns:a="http://schemas.openxmlformats.org/drawingml/2006/main">
               <a:ext uri="{FF2B5EF4-FFF2-40B4-BE49-F238E27FC236}">
-                <a16:creationId xmlns:a16="http://schemas.microsoft.com/office/drawing/2014/main" id="{84DB543E-4DEA-48E7-9038-88AB1D9D2FC0}"/>
+                <a16:creationId xmlns:a16="http://schemas.microsoft.com/office/drawing/2014/main" id="{30906352-388E-45A6-AC68-D86DF59333AB}"/>
               </a:ext>
             </a:extLst>
           </p:cNvPr>
@@ -5273,7 +5273,7 @@
     </p:spTree>
     <p:extLst>
       <p:ext uri="{BB962C8B-B14F-4D97-AF65-F5344CB8AC3E}">
-        <p14:creationId xmlns:p14="http://schemas.microsoft.com/office/powerpoint/2010/main" val="1478570728"/>
+        <p14:creationId xmlns:p14="http://schemas.microsoft.com/office/powerpoint/2010/main" val="1714981512"/>
       </p:ext>
     </p:extLst>
   </p:cSld>
@@ -5304,7 +5304,7 @@
           <p:cNvPr id="28" name="SCAMSHIELD  /  CONCEPT PITCH">
             <a:extLst xmlns:a="http://schemas.openxmlformats.org/drawingml/2006/main">
               <a:ext uri="{FF2B5EF4-FFF2-40B4-BE49-F238E27FC236}">
-                <a16:creationId xmlns:a16="http://schemas.microsoft.com/office/drawing/2014/main" id="{9DE7E46F-05BE-4214-A3E1-988BD6C6A80D}"/>
+                <a16:creationId xmlns:a16="http://schemas.microsoft.com/office/drawing/2014/main" id="{8F661560-03A0-4DE9-97C1-CDA9159AB9AB}"/>
               </a:ext>
             </a:extLst>
           </p:cNvPr>
@@ -5377,7 +5377,7 @@
           <p:cNvPr id="2" name="03  /  06">
             <a:extLst xmlns:a="http://schemas.openxmlformats.org/drawingml/2006/main">
               <a:ext uri="{FF2B5EF4-FFF2-40B4-BE49-F238E27FC236}">
-                <a16:creationId xmlns:a16="http://schemas.microsoft.com/office/drawing/2014/main" id="{7D2A4B3E-6AAB-4EF9-A9EE-9F77068DB121}"/>
+                <a16:creationId xmlns:a16="http://schemas.microsoft.com/office/drawing/2014/main" id="{D664BD4D-2490-4B37-8276-1F7CC8E0ABAC}"/>
               </a:ext>
             </a:extLst>
           </p:cNvPr>
@@ -5450,7 +5450,7 @@
           <p:cNvPr id="3" name="">
             <a:extLst xmlns:a="http://schemas.openxmlformats.org/drawingml/2006/main">
               <a:ext uri="{FF2B5EF4-FFF2-40B4-BE49-F238E27FC236}">
-                <a16:creationId xmlns:a16="http://schemas.microsoft.com/office/drawing/2014/main" id="{69887086-D332-46CE-9117-D6D8DCA1E574}"/>
+                <a16:creationId xmlns:a16="http://schemas.microsoft.com/office/drawing/2014/main" id="{DABC25C2-EE5B-436B-86F1-A7687E972320}"/>
               </a:ext>
             </a:extLst>
           </p:cNvPr>
@@ -5481,7 +5481,7 @@
           <p:cNvPr id="4" name="Two payment paths share one decision eng">
             <a:extLst xmlns:a="http://schemas.openxmlformats.org/drawingml/2006/main">
               <a:ext uri="{FF2B5EF4-FFF2-40B4-BE49-F238E27FC236}">
-                <a16:creationId xmlns:a16="http://schemas.microsoft.com/office/drawing/2014/main" id="{BA3CE98D-8975-495C-9312-ED713941F04A}"/>
+                <a16:creationId xmlns:a16="http://schemas.microsoft.com/office/drawing/2014/main" id="{AC3D9353-F263-4D2D-B807-8697E2B6B93D}"/>
               </a:ext>
             </a:extLst>
           </p:cNvPr>
@@ -5554,7 +5554,7 @@
           <p:cNvPr id="5" name="Adapters retain the details each workflo">
             <a:extLst xmlns:a="http://schemas.openxmlformats.org/drawingml/2006/main">
               <a:ext uri="{FF2B5EF4-FFF2-40B4-BE49-F238E27FC236}">
-                <a16:creationId xmlns:a16="http://schemas.microsoft.com/office/drawing/2014/main" id="{1B1506CC-42C5-43AA-9B4D-A23B8ADE9F39}"/>
+                <a16:creationId xmlns:a16="http://schemas.microsoft.com/office/drawing/2014/main" id="{8AE0CFAD-6F4E-4B2D-8CA7-FD269740F53C}"/>
               </a:ext>
             </a:extLst>
           </p:cNvPr>
@@ -5627,7 +5627,7 @@
           <p:cNvPr id="6" name="01">
             <a:extLst xmlns:a="http://schemas.openxmlformats.org/drawingml/2006/main">
               <a:ext uri="{FF2B5EF4-FFF2-40B4-BE49-F238E27FC236}">
-                <a16:creationId xmlns:a16="http://schemas.microsoft.com/office/drawing/2014/main" id="{7348B773-56BC-4E8D-8299-7F362DAC20EC}"/>
+                <a16:creationId xmlns:a16="http://schemas.microsoft.com/office/drawing/2014/main" id="{DB4957EF-5ADA-4DD9-9777-2FC9506FB25B}"/>
               </a:ext>
             </a:extLst>
           </p:cNvPr>
@@ -5700,7 +5700,7 @@
           <p:cNvPr id="7" name="Consumer transfer">
             <a:extLst xmlns:a="http://schemas.openxmlformats.org/drawingml/2006/main">
               <a:ext uri="{FF2B5EF4-FFF2-40B4-BE49-F238E27FC236}">
-                <a16:creationId xmlns:a16="http://schemas.microsoft.com/office/drawing/2014/main" id="{13268779-37A2-4EB2-B7A8-075E27B83D44}"/>
+                <a16:creationId xmlns:a16="http://schemas.microsoft.com/office/drawing/2014/main" id="{DF41B7AF-20F9-4804-BED1-1DA3C468D5B2}"/>
               </a:ext>
             </a:extLst>
           </p:cNvPr>
@@ -5773,7 +5773,7 @@
           <p:cNvPr id="8" name="Capture amount, UPI recipient and option">
             <a:extLst xmlns:a="http://schemas.openxmlformats.org/drawingml/2006/main">
               <a:ext uri="{FF2B5EF4-FFF2-40B4-BE49-F238E27FC236}">
-                <a16:creationId xmlns:a16="http://schemas.microsoft.com/office/drawing/2014/main" id="{B49E7EC9-DF11-47A8-81AF-6876AADCC70B}"/>
+                <a16:creationId xmlns:a16="http://schemas.microsoft.com/office/drawing/2014/main" id="{0C21FBBD-0B40-4ECA-996B-DE8F4F51C0C6}"/>
               </a:ext>
             </a:extLst>
           </p:cNvPr>
@@ -5873,7 +5873,7 @@
           <p:cNvPr id="9" name="02">
             <a:extLst xmlns:a="http://schemas.openxmlformats.org/drawingml/2006/main">
               <a:ext uri="{FF2B5EF4-FFF2-40B4-BE49-F238E27FC236}">
-                <a16:creationId xmlns:a16="http://schemas.microsoft.com/office/drawing/2014/main" id="{702D6FA1-CB39-4A57-BD6A-58326DE72DD7}"/>
+                <a16:creationId xmlns:a16="http://schemas.microsoft.com/office/drawing/2014/main" id="{50FB535A-C5BB-4956-86FC-3ECFBB4619B8}"/>
               </a:ext>
             </a:extLst>
           </p:cNvPr>
@@ -5946,7 +5946,7 @@
           <p:cNvPr id="10" name="Invoice payment">
             <a:extLst xmlns:a="http://schemas.openxmlformats.org/drawingml/2006/main">
               <a:ext uri="{FF2B5EF4-FFF2-40B4-BE49-F238E27FC236}">
-                <a16:creationId xmlns:a16="http://schemas.microsoft.com/office/drawing/2014/main" id="{D8AA8439-CE1A-437C-8DFB-02E65E3C040A}"/>
+                <a16:creationId xmlns:a16="http://schemas.microsoft.com/office/drawing/2014/main" id="{00F3697E-B991-48D3-A1D2-B6FF355634B4}"/>
               </a:ext>
             </a:extLst>
           </p:cNvPr>
@@ -6019,7 +6019,7 @@
           <p:cNvPr id="11" name="Capture invoice amount, vendor and reque">
             <a:extLst xmlns:a="http://schemas.openxmlformats.org/drawingml/2006/main">
               <a:ext uri="{FF2B5EF4-FFF2-40B4-BE49-F238E27FC236}">
-                <a16:creationId xmlns:a16="http://schemas.microsoft.com/office/drawing/2014/main" id="{0027E0B0-0152-4F99-AA43-D496E4F7E0A0}"/>
+                <a16:creationId xmlns:a16="http://schemas.microsoft.com/office/drawing/2014/main" id="{7E23E24B-EE74-4DB3-BB6B-2721A8F793D5}"/>
               </a:ext>
             </a:extLst>
           </p:cNvPr>
@@ -6119,7 +6119,7 @@
           <p:cNvPr id="12" name="">
             <a:extLst xmlns:a="http://schemas.openxmlformats.org/drawingml/2006/main">
               <a:ext uri="{FF2B5EF4-FFF2-40B4-BE49-F238E27FC236}">
-                <a16:creationId xmlns:a16="http://schemas.microsoft.com/office/drawing/2014/main" id="{B0025A9D-FDC3-4A19-BA97-0D2B58DF2B8B}"/>
+                <a16:creationId xmlns:a16="http://schemas.microsoft.com/office/drawing/2014/main" id="{EC10197E-6C77-4C11-9969-9C7BA4F1580E}"/>
               </a:ext>
             </a:extLst>
           </p:cNvPr>
@@ -6150,7 +6150,7 @@
           <p:cNvPr id="13" name="SHARED ENGINE">
             <a:extLst xmlns:a="http://schemas.openxmlformats.org/drawingml/2006/main">
               <a:ext uri="{FF2B5EF4-FFF2-40B4-BE49-F238E27FC236}">
-                <a16:creationId xmlns:a16="http://schemas.microsoft.com/office/drawing/2014/main" id="{47D6C70A-F570-4528-ADF4-B6B7FB357E66}"/>
+                <a16:creationId xmlns:a16="http://schemas.microsoft.com/office/drawing/2014/main" id="{D6439A90-A119-4FA6-ABFE-3F91D9DA0C54}"/>
               </a:ext>
             </a:extLst>
           </p:cNvPr>
@@ -6223,7 +6223,7 @@
           <p:cNvPr id="14" name="01">
             <a:extLst xmlns:a="http://schemas.openxmlformats.org/drawingml/2006/main">
               <a:ext uri="{FF2B5EF4-FFF2-40B4-BE49-F238E27FC236}">
-                <a16:creationId xmlns:a16="http://schemas.microsoft.com/office/drawing/2014/main" id="{616B1598-5748-44CC-A096-75568412B345}"/>
+                <a16:creationId xmlns:a16="http://schemas.microsoft.com/office/drawing/2014/main" id="{C6473075-1399-46EA-8464-B6BE6F3490B8}"/>
               </a:ext>
             </a:extLst>
           </p:cNvPr>
@@ -6296,7 +6296,7 @@
           <p:cNvPr id="15" name="Normalize">
             <a:extLst xmlns:a="http://schemas.openxmlformats.org/drawingml/2006/main">
               <a:ext uri="{FF2B5EF4-FFF2-40B4-BE49-F238E27FC236}">
-                <a16:creationId xmlns:a16="http://schemas.microsoft.com/office/drawing/2014/main" id="{70EDB549-29C8-4846-9B76-AD2DE22A3422}"/>
+                <a16:creationId xmlns:a16="http://schemas.microsoft.com/office/drawing/2014/main" id="{90294FF0-6BC0-49F4-BBDD-CC28F68D5F2F}"/>
               </a:ext>
             </a:extLst>
           </p:cNvPr>
@@ -6369,7 +6369,7 @@
           <p:cNvPr id="16" name="One transaction contract">
             <a:extLst xmlns:a="http://schemas.openxmlformats.org/drawingml/2006/main">
               <a:ext uri="{FF2B5EF4-FFF2-40B4-BE49-F238E27FC236}">
-                <a16:creationId xmlns:a16="http://schemas.microsoft.com/office/drawing/2014/main" id="{048E2636-7F59-430B-B575-59546A628596}"/>
+                <a16:creationId xmlns:a16="http://schemas.microsoft.com/office/drawing/2014/main" id="{B55C2392-B186-4F98-893F-0F78F4E09E22}"/>
               </a:ext>
             </a:extLst>
           </p:cNvPr>
@@ -6442,7 +6442,7 @@
           <p:cNvPr id="17" name="02">
             <a:extLst xmlns:a="http://schemas.openxmlformats.org/drawingml/2006/main">
               <a:ext uri="{FF2B5EF4-FFF2-40B4-BE49-F238E27FC236}">
-                <a16:creationId xmlns:a16="http://schemas.microsoft.com/office/drawing/2014/main" id="{2988E6F8-A26B-4E1B-924B-355D8F65AFED}"/>
+                <a16:creationId xmlns:a16="http://schemas.microsoft.com/office/drawing/2014/main" id="{3F78A803-688C-4C79-9204-9FCD18B94497}"/>
               </a:ext>
             </a:extLst>
           </p:cNvPr>
@@ -6515,7 +6515,7 @@
           <p:cNvPr id="18" name="Find evidence">
             <a:extLst xmlns:a="http://schemas.openxmlformats.org/drawingml/2006/main">
               <a:ext uri="{FF2B5EF4-FFF2-40B4-BE49-F238E27FC236}">
-                <a16:creationId xmlns:a16="http://schemas.microsoft.com/office/drawing/2014/main" id="{CB95EA17-3FA4-45C8-A1E3-E38F3A3C07B4}"/>
+                <a16:creationId xmlns:a16="http://schemas.microsoft.com/office/drawing/2014/main" id="{E9595376-A058-43ED-9E7A-5C4269D3F273}"/>
               </a:ext>
             </a:extLst>
           </p:cNvPr>
@@ -6588,7 +6588,7 @@
           <p:cNvPr id="19" name="Rules plus optional context">
             <a:extLst xmlns:a="http://schemas.openxmlformats.org/drawingml/2006/main">
               <a:ext uri="{FF2B5EF4-FFF2-40B4-BE49-F238E27FC236}">
-                <a16:creationId xmlns:a16="http://schemas.microsoft.com/office/drawing/2014/main" id="{E84D1039-ACFF-451F-913D-AAADD804FE9D}"/>
+                <a16:creationId xmlns:a16="http://schemas.microsoft.com/office/drawing/2014/main" id="{EA2B8828-99F8-471D-99A0-C20595C65A91}"/>
               </a:ext>
             </a:extLst>
           </p:cNvPr>
@@ -6661,7 +6661,7 @@
           <p:cNvPr id="20" name="03">
             <a:extLst xmlns:a="http://schemas.openxmlformats.org/drawingml/2006/main">
               <a:ext uri="{FF2B5EF4-FFF2-40B4-BE49-F238E27FC236}">
-                <a16:creationId xmlns:a16="http://schemas.microsoft.com/office/drawing/2014/main" id="{0A51EDF3-95EE-45C5-A928-B4C0C5837791}"/>
+                <a16:creationId xmlns:a16="http://schemas.microsoft.com/office/drawing/2014/main" id="{DCFB40A9-293C-43D5-B1EA-EBDEE34EC213}"/>
               </a:ext>
             </a:extLst>
           </p:cNvPr>
@@ -6734,7 +6734,7 @@
           <p:cNvPr id="21" name="Apply policy">
             <a:extLst xmlns:a="http://schemas.openxmlformats.org/drawingml/2006/main">
               <a:ext uri="{FF2B5EF4-FFF2-40B4-BE49-F238E27FC236}">
-                <a16:creationId xmlns:a16="http://schemas.microsoft.com/office/drawing/2014/main" id="{ED418FBE-12D4-4A48-ABC1-5C8B393F4028}"/>
+                <a16:creationId xmlns:a16="http://schemas.microsoft.com/office/drawing/2014/main" id="{C34D3E77-B4E8-4B0B-811D-4B585795163F}"/>
               </a:ext>
             </a:extLst>
           </p:cNvPr>
@@ -6807,7 +6807,7 @@
           <p:cNvPr id="22" name="Continue · verify · review">
             <a:extLst xmlns:a="http://schemas.openxmlformats.org/drawingml/2006/main">
               <a:ext uri="{FF2B5EF4-FFF2-40B4-BE49-F238E27FC236}">
-                <a16:creationId xmlns:a16="http://schemas.microsoft.com/office/drawing/2014/main" id="{4CE9507F-3985-4456-B6F1-9D90B9D4D99A}"/>
+                <a16:creationId xmlns:a16="http://schemas.microsoft.com/office/drawing/2014/main" id="{DC169477-9E13-4938-8FFC-642BA18CEDCB}"/>
               </a:ext>
             </a:extLst>
           </p:cNvPr>
@@ -6880,7 +6880,7 @@
           <p:cNvPr id="23" name="04">
             <a:extLst xmlns:a="http://schemas.openxmlformats.org/drawingml/2006/main">
               <a:ext uri="{FF2B5EF4-FFF2-40B4-BE49-F238E27FC236}">
-                <a16:creationId xmlns:a16="http://schemas.microsoft.com/office/drawing/2014/main" id="{AB1BBAA5-991F-4AC1-83E8-A817A588EE0E}"/>
+                <a16:creationId xmlns:a16="http://schemas.microsoft.com/office/drawing/2014/main" id="{2BF2A852-86B5-4617-B8ED-6EED8E7B37CD}"/>
               </a:ext>
             </a:extLst>
           </p:cNvPr>
@@ -6953,7 +6953,7 @@
           <p:cNvPr id="24" name="Explain">
             <a:extLst xmlns:a="http://schemas.openxmlformats.org/drawingml/2006/main">
               <a:ext uri="{FF2B5EF4-FFF2-40B4-BE49-F238E27FC236}">
-                <a16:creationId xmlns:a16="http://schemas.microsoft.com/office/drawing/2014/main" id="{295D9A9D-79D2-47F5-BC2A-B70173756A64}"/>
+                <a16:creationId xmlns:a16="http://schemas.microsoft.com/office/drawing/2014/main" id="{55764A27-993F-48C2-A638-D95D82039AB7}"/>
               </a:ext>
             </a:extLst>
           </p:cNvPr>
@@ -7026,7 +7026,7 @@
           <p:cNvPr id="25" name="Evidence-grounded summary">
             <a:extLst xmlns:a="http://schemas.openxmlformats.org/drawingml/2006/main">
               <a:ext uri="{FF2B5EF4-FFF2-40B4-BE49-F238E27FC236}">
-                <a16:creationId xmlns:a16="http://schemas.microsoft.com/office/drawing/2014/main" id="{4BDDC913-BD53-4E9A-BCB4-D1339CDC638C}"/>
+                <a16:creationId xmlns:a16="http://schemas.microsoft.com/office/drawing/2014/main" id="{A79561A7-6A30-413F-8A06-BA08F9271DDE}"/>
               </a:ext>
             </a:extLst>
           </p:cNvPr>
@@ -7099,7 +7099,7 @@
           <p:cNvPr id="26" name="">
             <a:extLst xmlns:a="http://schemas.openxmlformats.org/drawingml/2006/main">
               <a:ext uri="{FF2B5EF4-FFF2-40B4-BE49-F238E27FC236}">
-                <a16:creationId xmlns:a16="http://schemas.microsoft.com/office/drawing/2014/main" id="{161925E3-9084-485E-BC1B-15EDD7705116}"/>
+                <a16:creationId xmlns:a16="http://schemas.microsoft.com/office/drawing/2014/main" id="{B1889CBC-75B5-4749-BD52-DAAAC98EF3A9}"/>
               </a:ext>
             </a:extLst>
           </p:cNvPr>
@@ -7130,7 +7130,7 @@
           <p:cNvPr id="27" name="Synthetic demonstration concept  /  No p">
             <a:extLst xmlns:a="http://schemas.openxmlformats.org/drawingml/2006/main">
               <a:ext uri="{FF2B5EF4-FFF2-40B4-BE49-F238E27FC236}">
-                <a16:creationId xmlns:a16="http://schemas.microsoft.com/office/drawing/2014/main" id="{C9260AB9-5152-4539-8A01-96298C2C8B49}"/>
+                <a16:creationId xmlns:a16="http://schemas.microsoft.com/office/drawing/2014/main" id="{4479E562-BA59-4CDD-9912-345400AE7CE5}"/>
               </a:ext>
             </a:extLst>
           </p:cNvPr>
@@ -7201,7 +7201,7 @@
     </p:spTree>
     <p:extLst>
       <p:ext uri="{BB962C8B-B14F-4D97-AF65-F5344CB8AC3E}">
-        <p14:creationId xmlns:p14="http://schemas.microsoft.com/office/powerpoint/2010/main" val="77533217"/>
+        <p14:creationId xmlns:p14="http://schemas.microsoft.com/office/powerpoint/2010/main" val="688859432"/>
       </p:ext>
     </p:extLst>
   </p:cSld>
@@ -7232,7 +7232,7 @@
           <p:cNvPr id="30" name="SCAMSHIELD  /  CONCEPT PITCH">
             <a:extLst xmlns:a="http://schemas.openxmlformats.org/drawingml/2006/main">
               <a:ext uri="{FF2B5EF4-FFF2-40B4-BE49-F238E27FC236}">
-                <a16:creationId xmlns:a16="http://schemas.microsoft.com/office/drawing/2014/main" id="{37AEC040-A184-46C9-9F3C-CD9E077F3762}"/>
+                <a16:creationId xmlns:a16="http://schemas.microsoft.com/office/drawing/2014/main" id="{EDD87680-B44E-4206-B3FB-8935402553A2}"/>
               </a:ext>
             </a:extLst>
           </p:cNvPr>
@@ -7305,7 +7305,7 @@
           <p:cNvPr id="2" name="04  /  06">
             <a:extLst xmlns:a="http://schemas.openxmlformats.org/drawingml/2006/main">
               <a:ext uri="{FF2B5EF4-FFF2-40B4-BE49-F238E27FC236}">
-                <a16:creationId xmlns:a16="http://schemas.microsoft.com/office/drawing/2014/main" id="{573F6765-08A4-4FFA-A2D8-6CA410C37081}"/>
+                <a16:creationId xmlns:a16="http://schemas.microsoft.com/office/drawing/2014/main" id="{A85518F3-95BC-484F-B4C6-E16C9EA75D4B}"/>
               </a:ext>
             </a:extLst>
           </p:cNvPr>
@@ -7378,7 +7378,7 @@
           <p:cNvPr id="3" name="">
             <a:extLst xmlns:a="http://schemas.openxmlformats.org/drawingml/2006/main">
               <a:ext uri="{FF2B5EF4-FFF2-40B4-BE49-F238E27FC236}">
-                <a16:creationId xmlns:a16="http://schemas.microsoft.com/office/drawing/2014/main" id="{E6CA6E45-D65F-4114-86C2-D6C41A743BEC}"/>
+                <a16:creationId xmlns:a16="http://schemas.microsoft.com/office/drawing/2014/main" id="{28045537-ED8A-4ACA-BDD8-D286BECAF386}"/>
               </a:ext>
             </a:extLst>
           </p:cNvPr>
@@ -7409,7 +7409,7 @@
           <p:cNvPr id="4" name="Keep evidence, policy and explanation se">
             <a:extLst xmlns:a="http://schemas.openxmlformats.org/drawingml/2006/main">
               <a:ext uri="{FF2B5EF4-FFF2-40B4-BE49-F238E27FC236}">
-                <a16:creationId xmlns:a16="http://schemas.microsoft.com/office/drawing/2014/main" id="{8E1319DA-D777-4B1F-AE50-FE0567DAFDD8}"/>
+                <a16:creationId xmlns:a16="http://schemas.microsoft.com/office/drawing/2014/main" id="{46466E08-6B7B-4329-94D9-A607AC81F5CA}"/>
               </a:ext>
             </a:extLst>
           </p:cNvPr>
@@ -7482,7 +7482,7 @@
           <p:cNvPr id="5" name="Each stage has a bounded job. Model outp">
             <a:extLst xmlns:a="http://schemas.openxmlformats.org/drawingml/2006/main">
               <a:ext uri="{FF2B5EF4-FFF2-40B4-BE49-F238E27FC236}">
-                <a16:creationId xmlns:a16="http://schemas.microsoft.com/office/drawing/2014/main" id="{2BA29611-1764-422D-A988-6B1529CC1F9B}"/>
+                <a16:creationId xmlns:a16="http://schemas.microsoft.com/office/drawing/2014/main" id="{EE7CD2C4-E363-4C7B-B5D7-72BFF3099662}"/>
               </a:ext>
             </a:extLst>
           </p:cNvPr>
@@ -7555,7 +7555,7 @@
           <p:cNvPr id="6" name="01">
             <a:extLst xmlns:a="http://schemas.openxmlformats.org/drawingml/2006/main">
               <a:ext uri="{FF2B5EF4-FFF2-40B4-BE49-F238E27FC236}">
-                <a16:creationId xmlns:a16="http://schemas.microsoft.com/office/drawing/2014/main" id="{02C9602F-FBC9-4CB3-8231-7E13ECE8DBA3}"/>
+                <a16:creationId xmlns:a16="http://schemas.microsoft.com/office/drawing/2014/main" id="{051A0078-D1E8-4723-A38C-BA7FF5FA5DAC}"/>
               </a:ext>
             </a:extLst>
           </p:cNvPr>
@@ -7628,7 +7628,7 @@
           <p:cNvPr id="7" name="ADAPTERS">
             <a:extLst xmlns:a="http://schemas.openxmlformats.org/drawingml/2006/main">
               <a:ext uri="{FF2B5EF4-FFF2-40B4-BE49-F238E27FC236}">
-                <a16:creationId xmlns:a16="http://schemas.microsoft.com/office/drawing/2014/main" id="{46AF441C-6DE6-43F3-9E22-7526A97F314D}"/>
+                <a16:creationId xmlns:a16="http://schemas.microsoft.com/office/drawing/2014/main" id="{FC801B4E-72E5-4F9E-9844-6D7B5B5F7BF2}"/>
               </a:ext>
             </a:extLst>
           </p:cNvPr>
@@ -7701,7 +7701,7 @@
           <p:cNvPr id="8" name="UPI transfer  /  Vendor invoice">
             <a:extLst xmlns:a="http://schemas.openxmlformats.org/drawingml/2006/main">
               <a:ext uri="{FF2B5EF4-FFF2-40B4-BE49-F238E27FC236}">
-                <a16:creationId xmlns:a16="http://schemas.microsoft.com/office/drawing/2014/main" id="{9471D201-48E7-48AD-9911-ECF1304BEB8A}"/>
+                <a16:creationId xmlns:a16="http://schemas.microsoft.com/office/drawing/2014/main" id="{604CD637-56E9-4F96-A813-DA7141A677E1}"/>
               </a:ext>
             </a:extLst>
           </p:cNvPr>
@@ -7774,7 +7774,7 @@
           <p:cNvPr id="9" name="Validate fields and normalize the reques">
             <a:extLst xmlns:a="http://schemas.openxmlformats.org/drawingml/2006/main">
               <a:ext uri="{FF2B5EF4-FFF2-40B4-BE49-F238E27FC236}">
-                <a16:creationId xmlns:a16="http://schemas.microsoft.com/office/drawing/2014/main" id="{6F88ADB1-E381-4D77-9F3D-9A4B39E68CCE}"/>
+                <a16:creationId xmlns:a16="http://schemas.microsoft.com/office/drawing/2014/main" id="{24025A2C-A608-4BE3-B029-A069B99772C5}"/>
               </a:ext>
             </a:extLst>
           </p:cNvPr>
@@ -7847,7 +7847,7 @@
           <p:cNvPr id="10" name="">
             <a:extLst xmlns:a="http://schemas.openxmlformats.org/drawingml/2006/main">
               <a:ext uri="{FF2B5EF4-FFF2-40B4-BE49-F238E27FC236}">
-                <a16:creationId xmlns:a16="http://schemas.microsoft.com/office/drawing/2014/main" id="{66B79CD7-9E5F-438D-B3B4-58656D62A931}"/>
+                <a16:creationId xmlns:a16="http://schemas.microsoft.com/office/drawing/2014/main" id="{EFF38E6F-5354-4174-957B-AB2749149DBA}"/>
               </a:ext>
             </a:extLst>
           </p:cNvPr>
@@ -7878,7 +7878,7 @@
           <p:cNvPr id="11" name="02">
             <a:extLst xmlns:a="http://schemas.openxmlformats.org/drawingml/2006/main">
               <a:ext uri="{FF2B5EF4-FFF2-40B4-BE49-F238E27FC236}">
-                <a16:creationId xmlns:a16="http://schemas.microsoft.com/office/drawing/2014/main" id="{D0C5B1BD-7F73-478D-92B7-A96368024F3B}"/>
+                <a16:creationId xmlns:a16="http://schemas.microsoft.com/office/drawing/2014/main" id="{5226E719-351B-4C18-8590-3612303CEDF1}"/>
               </a:ext>
             </a:extLst>
           </p:cNvPr>
@@ -7951,7 +7951,7 @@
           <p:cNvPr id="12" name="EVIDENCE">
             <a:extLst xmlns:a="http://schemas.openxmlformats.org/drawingml/2006/main">
               <a:ext uri="{FF2B5EF4-FFF2-40B4-BE49-F238E27FC236}">
-                <a16:creationId xmlns:a16="http://schemas.microsoft.com/office/drawing/2014/main" id="{FB95FEA1-A2C3-4880-8D61-999E4CC7A447}"/>
+                <a16:creationId xmlns:a16="http://schemas.microsoft.com/office/drawing/2014/main" id="{4F0B71DF-7AA9-4856-B443-503B3FA1F3B1}"/>
               </a:ext>
             </a:extLst>
           </p:cNvPr>
@@ -8024,7 +8024,7 @@
           <p:cNvPr id="13" name="Rules  +  optional context classificatio">
             <a:extLst xmlns:a="http://schemas.openxmlformats.org/drawingml/2006/main">
               <a:ext uri="{FF2B5EF4-FFF2-40B4-BE49-F238E27FC236}">
-                <a16:creationId xmlns:a16="http://schemas.microsoft.com/office/drawing/2014/main" id="{0CF555E2-35CD-4BF2-A58D-01A2D0E9C168}"/>
+                <a16:creationId xmlns:a16="http://schemas.microsoft.com/office/drawing/2014/main" id="{E1C8915B-AECA-4C3B-B491-7D76B4E38F6E}"/>
               </a:ext>
             </a:extLst>
           </p:cNvPr>
@@ -8094,10 +8094,10 @@
       </p:sp>
       <p:sp>
         <p:nvSpPr>
-          <p:cNvPr id="14" name="Jev or Gemini on Vertex AI, selected by ">
-            <a:extLst xmlns:a="http://schemas.openxmlformats.org/drawingml/2006/main">
-              <a:ext uri="{FF2B5EF4-FFF2-40B4-BE49-F238E27FC236}">
-                <a16:creationId xmlns:a16="http://schemas.microsoft.com/office/drawing/2014/main" id="{EE4438AF-CEC0-492A-A01B-D6C197D975BA}"/>
+          <p:cNvPr id="14" name="Gemini Developer API; Vertex AI remains ">
+            <a:extLst xmlns:a="http://schemas.openxmlformats.org/drawingml/2006/main">
+              <a:ext uri="{FF2B5EF4-FFF2-40B4-BE49-F238E27FC236}">
+                <a16:creationId xmlns:a16="http://schemas.microsoft.com/office/drawing/2014/main" id="{C6B215A9-B8CC-4111-8252-25FDFD26DBFA}"/>
               </a:ext>
             </a:extLst>
           </p:cNvPr>
@@ -8160,7 +8160,7 @@
                 <a:ea typeface="Avenir Next"/>
                 <a:cs typeface="Avenir Next"/>
               </a:rPr>
-              <a:t>Jev or Gemini on Vertex AI, selected by configuration</a:t>
+              <a:t>Gemini Developer API; Vertex AI remains optional</a:t>
             </a:r>
           </a:p>
         </p:txBody>
@@ -8170,7 +8170,7 @@
           <p:cNvPr id="15" name="">
             <a:extLst xmlns:a="http://schemas.openxmlformats.org/drawingml/2006/main">
               <a:ext uri="{FF2B5EF4-FFF2-40B4-BE49-F238E27FC236}">
-                <a16:creationId xmlns:a16="http://schemas.microsoft.com/office/drawing/2014/main" id="{8DC82A08-2778-4F12-B609-E16914C89CA0}"/>
+                <a16:creationId xmlns:a16="http://schemas.microsoft.com/office/drawing/2014/main" id="{A13C65E1-05DD-40E7-B2B5-8188F1B487C7}"/>
               </a:ext>
             </a:extLst>
           </p:cNvPr>
@@ -8201,7 +8201,7 @@
           <p:cNvPr id="16" name="03">
             <a:extLst xmlns:a="http://schemas.openxmlformats.org/drawingml/2006/main">
               <a:ext uri="{FF2B5EF4-FFF2-40B4-BE49-F238E27FC236}">
-                <a16:creationId xmlns:a16="http://schemas.microsoft.com/office/drawing/2014/main" id="{AF9BC2FA-C5AE-4BE4-8E2D-566C43A5B678}"/>
+                <a16:creationId xmlns:a16="http://schemas.microsoft.com/office/drawing/2014/main" id="{96388721-EE3E-45BC-972A-A4413F525AAF}"/>
               </a:ext>
             </a:extLst>
           </p:cNvPr>
@@ -8274,7 +8274,7 @@
           <p:cNvPr id="17" name="POLICY">
             <a:extLst xmlns:a="http://schemas.openxmlformats.org/drawingml/2006/main">
               <a:ext uri="{FF2B5EF4-FFF2-40B4-BE49-F238E27FC236}">
-                <a16:creationId xmlns:a16="http://schemas.microsoft.com/office/drawing/2014/main" id="{C196EB1E-F6E6-4943-8BF2-24846A806B06}"/>
+                <a16:creationId xmlns:a16="http://schemas.microsoft.com/office/drawing/2014/main" id="{0FEE91BD-8684-4EA6-81F3-57A031F68487}"/>
               </a:ext>
             </a:extLst>
           </p:cNvPr>
@@ -8347,7 +8347,7 @@
           <p:cNvPr id="18" name="Continue  /  Verify  /  Review">
             <a:extLst xmlns:a="http://schemas.openxmlformats.org/drawingml/2006/main">
               <a:ext uri="{FF2B5EF4-FFF2-40B4-BE49-F238E27FC236}">
-                <a16:creationId xmlns:a16="http://schemas.microsoft.com/office/drawing/2014/main" id="{C416C9DC-2024-4BDC-BDB4-13610ADADE8E}"/>
+                <a16:creationId xmlns:a16="http://schemas.microsoft.com/office/drawing/2014/main" id="{21BA07C2-7A1E-44AD-BB30-7B6CA3290A3C}"/>
               </a:ext>
             </a:extLst>
           </p:cNvPr>
@@ -8420,7 +8420,7 @@
           <p:cNvPr id="19" name="Versioned thresholds map evidence to a r">
             <a:extLst xmlns:a="http://schemas.openxmlformats.org/drawingml/2006/main">
               <a:ext uri="{FF2B5EF4-FFF2-40B4-BE49-F238E27FC236}">
-                <a16:creationId xmlns:a16="http://schemas.microsoft.com/office/drawing/2014/main" id="{79A43735-C774-4AA2-9E1C-9CA84CEA7162}"/>
+                <a16:creationId xmlns:a16="http://schemas.microsoft.com/office/drawing/2014/main" id="{1EC10051-4EF8-4078-8B9D-DA622EFECEB0}"/>
               </a:ext>
             </a:extLst>
           </p:cNvPr>
@@ -8493,7 +8493,7 @@
           <p:cNvPr id="20" name="">
             <a:extLst xmlns:a="http://schemas.openxmlformats.org/drawingml/2006/main">
               <a:ext uri="{FF2B5EF4-FFF2-40B4-BE49-F238E27FC236}">
-                <a16:creationId xmlns:a16="http://schemas.microsoft.com/office/drawing/2014/main" id="{8997A3B0-478F-4CED-B818-A1B6A5961CD6}"/>
+                <a16:creationId xmlns:a16="http://schemas.microsoft.com/office/drawing/2014/main" id="{895E482E-CC85-4712-99FA-1DE84FFB234F}"/>
               </a:ext>
             </a:extLst>
           </p:cNvPr>
@@ -8524,7 +8524,7 @@
           <p:cNvPr id="21" name="04">
             <a:extLst xmlns:a="http://schemas.openxmlformats.org/drawingml/2006/main">
               <a:ext uri="{FF2B5EF4-FFF2-40B4-BE49-F238E27FC236}">
-                <a16:creationId xmlns:a16="http://schemas.microsoft.com/office/drawing/2014/main" id="{E22A1952-3F20-450F-AF12-B85933E4D491}"/>
+                <a16:creationId xmlns:a16="http://schemas.microsoft.com/office/drawing/2014/main" id="{72C06049-1B41-4142-AF0B-A8E50D9B6BC7}"/>
               </a:ext>
             </a:extLst>
           </p:cNvPr>
@@ -8597,7 +8597,7 @@
           <p:cNvPr id="22" name="EXPLANATION">
             <a:extLst xmlns:a="http://schemas.openxmlformats.org/drawingml/2006/main">
               <a:ext uri="{FF2B5EF4-FFF2-40B4-BE49-F238E27FC236}">
-                <a16:creationId xmlns:a16="http://schemas.microsoft.com/office/drawing/2014/main" id="{6137370C-4D28-4559-9CFE-977452CD059D}"/>
+                <a16:creationId xmlns:a16="http://schemas.microsoft.com/office/drawing/2014/main" id="{868797F7-E0D9-42F7-AA42-21DAD6BB24D2}"/>
               </a:ext>
             </a:extLst>
           </p:cNvPr>
@@ -8667,10 +8667,10 @@
       </p:sp>
       <p:sp>
         <p:nvSpPr>
-          <p:cNvPr id="23" name="Vertex AI Gemini summary">
-            <a:extLst xmlns:a="http://schemas.openxmlformats.org/drawingml/2006/main">
-              <a:ext uri="{FF2B5EF4-FFF2-40B4-BE49-F238E27FC236}">
-                <a16:creationId xmlns:a16="http://schemas.microsoft.com/office/drawing/2014/main" id="{B9D65311-EE2B-421D-8206-84D755904760}"/>
+          <p:cNvPr id="23" name="Gemini explanation">
+            <a:extLst xmlns:a="http://schemas.openxmlformats.org/drawingml/2006/main">
+              <a:ext uri="{FF2B5EF4-FFF2-40B4-BE49-F238E27FC236}">
+                <a16:creationId xmlns:a16="http://schemas.microsoft.com/office/drawing/2014/main" id="{47B83D12-E25C-4E5F-8C34-6C31BC6D5770}"/>
               </a:ext>
             </a:extLst>
           </p:cNvPr>
@@ -8733,17 +8733,17 @@
                 <a:ea typeface="Avenir Next"/>
                 <a:cs typeface="Avenir Next"/>
               </a:rPr>
-              <a:t>Vertex AI Gemini summary</a:t>
+              <a:t>Gemini explanation</a:t>
             </a:r>
           </a:p>
         </p:txBody>
       </p:sp>
       <p:sp>
         <p:nvSpPr>
-          <p:cNvPr id="24" name="Separate call after the decision is stor">
-            <a:extLst xmlns:a="http://schemas.openxmlformats.org/drawingml/2006/main">
-              <a:ext uri="{FF2B5EF4-FFF2-40B4-BE49-F238E27FC236}">
-                <a16:creationId xmlns:a16="http://schemas.microsoft.com/office/drawing/2014/main" id="{8A0AEB43-85A4-4269-AC1B-0D629192E99C}"/>
+          <p:cNvPr id="24" name="Separate optional call; deterministic fa">
+            <a:extLst xmlns:a="http://schemas.openxmlformats.org/drawingml/2006/main">
+              <a:ext uri="{FF2B5EF4-FFF2-40B4-BE49-F238E27FC236}">
+                <a16:creationId xmlns:a16="http://schemas.microsoft.com/office/drawing/2014/main" id="{2011D8D1-5772-41A3-80ED-ABE71584F070}"/>
               </a:ext>
             </a:extLst>
           </p:cNvPr>
@@ -8806,7 +8806,7 @@
                 <a:ea typeface="Avenir Next"/>
                 <a:cs typeface="Avenir Next"/>
               </a:rPr>
-              <a:t>Separate call after the decision is stored; fallback on failure</a:t>
+              <a:t>Separate optional call; deterministic fallback on failure</a:t>
             </a:r>
           </a:p>
         </p:txBody>
@@ -8816,7 +8816,7 @@
           <p:cNvPr id="25" name="">
             <a:extLst xmlns:a="http://schemas.openxmlformats.org/drawingml/2006/main">
               <a:ext uri="{FF2B5EF4-FFF2-40B4-BE49-F238E27FC236}">
-                <a16:creationId xmlns:a16="http://schemas.microsoft.com/office/drawing/2014/main" id="{C551543C-39C3-478F-82BE-1ACDAB98DF1D}"/>
+                <a16:creationId xmlns:a16="http://schemas.microsoft.com/office/drawing/2014/main" id="{792EECA1-88B8-43CC-8F88-9458A9EF184B}"/>
               </a:ext>
             </a:extLst>
           </p:cNvPr>
@@ -8844,10 +8844,10 @@
       </p:sp>
       <p:sp>
         <p:nvSpPr>
-          <p:cNvPr id="26" name="NOW">
-            <a:extLst xmlns:a="http://schemas.openxmlformats.org/drawingml/2006/main">
-              <a:ext uri="{FF2B5EF4-FFF2-40B4-BE49-F238E27FC236}">
-                <a16:creationId xmlns:a16="http://schemas.microsoft.com/office/drawing/2014/main" id="{30CF088E-AC50-4703-869C-BD11C2A5C158}"/>
+          <p:cNvPr id="26" name="HACKATHON PATH">
+            <a:extLst xmlns:a="http://schemas.openxmlformats.org/drawingml/2006/main">
+              <a:ext uri="{FF2B5EF4-FFF2-40B4-BE49-F238E27FC236}">
+                <a16:creationId xmlns:a16="http://schemas.microsoft.com/office/drawing/2014/main" id="{DBF96C88-5263-4F1F-8EDA-214609DEAFD4}"/>
               </a:ext>
             </a:extLst>
           </p:cNvPr>
@@ -8859,7 +8859,7 @@
         <p:spPr>
           <a:xfrm xmlns:a="http://schemas.openxmlformats.org/drawingml/2006/main">
             <a:off x="685800" y="6048375"/>
-            <a:ext cx="581025" cy="171450"/>
+            <a:ext cx="952500" cy="171450"/>
           </a:xfrm>
           <a:prstGeom xmlns:a="http://schemas.openxmlformats.org/drawingml/2006/main" prst="rect">
             <a:avLst/>
@@ -8872,7 +8872,7 @@
         </p:spPr>
         <p:txBody>
           <a:bodyPr xmlns:a="http://schemas.openxmlformats.org/drawingml/2006/main" wrap="square" lIns="0" tIns="0" rIns="0" bIns="0" anchor="t">
-            <a:normAutofit fontScale="100000"/>
+            <a:normAutofit fontScale="97014"/>
           </a:bodyPr>
           <a:lstStyle xmlns:a="http://schemas.openxmlformats.org/drawingml/2006/main">
             <a:defPPr algn="l">
@@ -8910,29 +8910,29 @@
                 <a:ea typeface="Avenir Next"/>
                 <a:cs typeface="Avenir Next"/>
               </a:rPr>
-              <a:t>NOW</a:t>
+              <a:t>HACKATHON PATH</a:t>
             </a:r>
           </a:p>
         </p:txBody>
       </p:sp>
       <p:sp>
         <p:nvSpPr>
-          <p:cNvPr id="27" name="Synthetic records  /  fixture mode avail">
-            <a:extLst xmlns:a="http://schemas.openxmlformats.org/drawingml/2006/main">
-              <a:ext uri="{FF2B5EF4-FFF2-40B4-BE49-F238E27FC236}">
-                <a16:creationId xmlns:a16="http://schemas.microsoft.com/office/drawing/2014/main" id="{35BCE8AA-F401-40D1-8274-CDB6E385275A}"/>
-              </a:ext>
-            </a:extLst>
-          </p:cNvPr>
-          <p:cNvSpPr>
-            <a:spLocks xmlns:a="http://schemas.openxmlformats.org/drawingml/2006/main" noGrp="1"/>
-          </p:cNvSpPr>
-          <p:nvPr/>
-        </p:nvSpPr>
-        <p:spPr>
-          <a:xfrm xmlns:a="http://schemas.openxmlformats.org/drawingml/2006/main">
-            <a:off x="1371600" y="6010275"/>
-            <a:ext cx="9334500" cy="238125"/>
+          <p:cNvPr id="27" name="Local app + SQLite + Gemini Developer AP">
+            <a:extLst xmlns:a="http://schemas.openxmlformats.org/drawingml/2006/main">
+              <a:ext uri="{FF2B5EF4-FFF2-40B4-BE49-F238E27FC236}">
+                <a16:creationId xmlns:a16="http://schemas.microsoft.com/office/drawing/2014/main" id="{3EF07466-1349-4126-96E1-2E521442183C}"/>
+              </a:ext>
+            </a:extLst>
+          </p:cNvPr>
+          <p:cNvSpPr>
+            <a:spLocks xmlns:a="http://schemas.openxmlformats.org/drawingml/2006/main" noGrp="1"/>
+          </p:cNvSpPr>
+          <p:nvPr/>
+        </p:nvSpPr>
+        <p:spPr>
+          <a:xfrm xmlns:a="http://schemas.openxmlformats.org/drawingml/2006/main">
+            <a:off x="1809750" y="6010275"/>
+            <a:ext cx="9048750" cy="238125"/>
           </a:xfrm>
           <a:prstGeom xmlns:a="http://schemas.openxmlformats.org/drawingml/2006/main" prst="rect">
             <a:avLst/>
@@ -8983,7 +8983,7 @@
                 <a:ea typeface="Avenir Next"/>
                 <a:cs typeface="Avenir Next"/>
               </a:rPr>
-              <a:t>Synthetic records  /  fixture mode available  /  integrations configurable and unverified</a:t>
+              <a:t>Local app + SQLite + Gemini Developer API free tier. Vertex AI and Cloud Run stay optional.</a:t>
             </a:r>
           </a:p>
         </p:txBody>
@@ -8993,7 +8993,7 @@
           <p:cNvPr id="28" name="">
             <a:extLst xmlns:a="http://schemas.openxmlformats.org/drawingml/2006/main">
               <a:ext uri="{FF2B5EF4-FFF2-40B4-BE49-F238E27FC236}">
-                <a16:creationId xmlns:a16="http://schemas.microsoft.com/office/drawing/2014/main" id="{9C5F7762-827F-4C31-9086-5D9A78EEC3BD}"/>
+                <a16:creationId xmlns:a16="http://schemas.microsoft.com/office/drawing/2014/main" id="{776F75D5-1756-422F-B6F1-F925E8A62696}"/>
               </a:ext>
             </a:extLst>
           </p:cNvPr>
@@ -9021,10 +9021,10 @@
       </p:sp>
       <p:sp>
         <p:nvSpPr>
-          <p:cNvPr id="29" name="Proposed architecture  /  Provider calls">
-            <a:extLst xmlns:a="http://schemas.openxmlformats.org/drawingml/2006/main">
-              <a:ext uri="{FF2B5EF4-FFF2-40B4-BE49-F238E27FC236}">
-                <a16:creationId xmlns:a16="http://schemas.microsoft.com/office/drawing/2014/main" id="{8BF6A507-F019-400F-A77E-46ECB73ED66D}"/>
+          <p:cNvPr id="29" name="Fixture default  /  Gemini live calls un">
+            <a:extLst xmlns:a="http://schemas.openxmlformats.org/drawingml/2006/main">
+              <a:ext uri="{FF2B5EF4-FFF2-40B4-BE49-F238E27FC236}">
+                <a16:creationId xmlns:a16="http://schemas.microsoft.com/office/drawing/2014/main" id="{E62D0B21-534F-4C94-A543-14304443491D}"/>
               </a:ext>
             </a:extLst>
           </p:cNvPr>
@@ -9087,7 +9087,7 @@
                 <a:ea typeface="Avenir Next"/>
                 <a:cs typeface="Avenir Next"/>
               </a:rPr>
-              <a:t>Proposed architecture  /  Provider calls remain on the backend</a:t>
+              <a:t>Fixture default  /  Gemini live calls unverified  /  Provider calls stay on backend</a:t>
             </a:r>
           </a:p>
         </p:txBody>
@@ -9095,7 +9095,7 @@
     </p:spTree>
     <p:extLst>
       <p:ext uri="{BB962C8B-B14F-4D97-AF65-F5344CB8AC3E}">
-        <p14:creationId xmlns:p14="http://schemas.microsoft.com/office/powerpoint/2010/main" val="1030301379"/>
+        <p14:creationId xmlns:p14="http://schemas.microsoft.com/office/powerpoint/2010/main" val="1228506379"/>
       </p:ext>
     </p:extLst>
   </p:cSld>
@@ -9126,7 +9126,7 @@
           <p:cNvPr id="41" name="SCAMSHIELD  /  CONCEPT PITCH">
             <a:extLst xmlns:a="http://schemas.openxmlformats.org/drawingml/2006/main">
               <a:ext uri="{FF2B5EF4-FFF2-40B4-BE49-F238E27FC236}">
-                <a16:creationId xmlns:a16="http://schemas.microsoft.com/office/drawing/2014/main" id="{9F71A517-7CF0-41E0-BC6B-4876E5898188}"/>
+                <a16:creationId xmlns:a16="http://schemas.microsoft.com/office/drawing/2014/main" id="{B0D3F791-858C-454C-8AAC-8DAC42657F6B}"/>
               </a:ext>
             </a:extLst>
           </p:cNvPr>
@@ -9199,7 +9199,7 @@
           <p:cNvPr id="2" name="05  /  06">
             <a:extLst xmlns:a="http://schemas.openxmlformats.org/drawingml/2006/main">
               <a:ext uri="{FF2B5EF4-FFF2-40B4-BE49-F238E27FC236}">
-                <a16:creationId xmlns:a16="http://schemas.microsoft.com/office/drawing/2014/main" id="{3E9CB0B2-2A0E-4878-8B2B-4F26BA5E923F}"/>
+                <a16:creationId xmlns:a16="http://schemas.microsoft.com/office/drawing/2014/main" id="{39F5D7DA-AC1F-4280-A60A-4261782B8FD8}"/>
               </a:ext>
             </a:extLst>
           </p:cNvPr>
@@ -9272,7 +9272,7 @@
           <p:cNvPr id="3" name="">
             <a:extLst xmlns:a="http://schemas.openxmlformats.org/drawingml/2006/main">
               <a:ext uri="{FF2B5EF4-FFF2-40B4-BE49-F238E27FC236}">
-                <a16:creationId xmlns:a16="http://schemas.microsoft.com/office/drawing/2014/main" id="{788F7132-11C0-4665-BAE7-1761432AD4F8}"/>
+                <a16:creationId xmlns:a16="http://schemas.microsoft.com/office/drawing/2014/main" id="{8EA42780-460C-4A6E-BEC9-0AE068FA3BEA}"/>
               </a:ext>
             </a:extLst>
           </p:cNvPr>
@@ -9303,7 +9303,7 @@
           <p:cNvPr id="4" name="Show the evidence, then measure the beha">
             <a:extLst xmlns:a="http://schemas.openxmlformats.org/drawingml/2006/main">
               <a:ext uri="{FF2B5EF4-FFF2-40B4-BE49-F238E27FC236}">
-                <a16:creationId xmlns:a16="http://schemas.microsoft.com/office/drawing/2014/main" id="{31146FBE-8929-46DB-9684-495195D96F4D}"/>
+                <a16:creationId xmlns:a16="http://schemas.microsoft.com/office/drawing/2014/main" id="{552E31F4-A79C-4A13-B93C-D501F741236F}"/>
               </a:ext>
             </a:extLst>
           </p:cNvPr>
@@ -9376,7 +9376,7 @@
           <p:cNvPr id="5" name="A short demo moves across both workflows">
             <a:extLst xmlns:a="http://schemas.openxmlformats.org/drawingml/2006/main">
               <a:ext uri="{FF2B5EF4-FFF2-40B4-BE49-F238E27FC236}">
-                <a16:creationId xmlns:a16="http://schemas.microsoft.com/office/drawing/2014/main" id="{45DCC20B-8982-476E-9DAA-9A71C6C8363D}"/>
+                <a16:creationId xmlns:a16="http://schemas.microsoft.com/office/drawing/2014/main" id="{63B30839-E31B-4B78-9E0E-688485E22842}"/>
               </a:ext>
             </a:extLst>
           </p:cNvPr>
@@ -9449,7 +9449,7 @@
           <p:cNvPr id="6" name="DEMO CASES">
             <a:extLst xmlns:a="http://schemas.openxmlformats.org/drawingml/2006/main">
               <a:ext uri="{FF2B5EF4-FFF2-40B4-BE49-F238E27FC236}">
-                <a16:creationId xmlns:a16="http://schemas.microsoft.com/office/drawing/2014/main" id="{EF23E62A-4E28-490D-969B-4E6C79A98278}"/>
+                <a16:creationId xmlns:a16="http://schemas.microsoft.com/office/drawing/2014/main" id="{F9D680E4-B3BC-42AA-B244-A669CC4C41E6}"/>
               </a:ext>
             </a:extLst>
           </p:cNvPr>
@@ -9522,7 +9522,7 @@
           <p:cNvPr id="7" name="01">
             <a:extLst xmlns:a="http://schemas.openxmlformats.org/drawingml/2006/main">
               <a:ext uri="{FF2B5EF4-FFF2-40B4-BE49-F238E27FC236}">
-                <a16:creationId xmlns:a16="http://schemas.microsoft.com/office/drawing/2014/main" id="{EAE3F35D-CEBD-4AE3-B5E3-106E624658CF}"/>
+                <a16:creationId xmlns:a16="http://schemas.microsoft.com/office/drawing/2014/main" id="{C2097F6D-9E7E-44FD-B6BF-A2BB29220CA2}"/>
               </a:ext>
             </a:extLst>
           </p:cNvPr>
@@ -9595,7 +9595,7 @@
           <p:cNvPr id="8" name="Safe-account message, new UPI recipient">
             <a:extLst xmlns:a="http://schemas.openxmlformats.org/drawingml/2006/main">
               <a:ext uri="{FF2B5EF4-FFF2-40B4-BE49-F238E27FC236}">
-                <a16:creationId xmlns:a16="http://schemas.microsoft.com/office/drawing/2014/main" id="{1B115229-C858-481F-88EA-05FD991567E9}"/>
+                <a16:creationId xmlns:a16="http://schemas.microsoft.com/office/drawing/2014/main" id="{93EE12FD-5FDF-42F7-A673-F584040B2946}"/>
               </a:ext>
             </a:extLst>
           </p:cNvPr>
@@ -9668,7 +9668,7 @@
           <p:cNvPr id="9" name="REVIEW">
             <a:extLst xmlns:a="http://schemas.openxmlformats.org/drawingml/2006/main">
               <a:ext uri="{FF2B5EF4-FFF2-40B4-BE49-F238E27FC236}">
-                <a16:creationId xmlns:a16="http://schemas.microsoft.com/office/drawing/2014/main" id="{56811A61-29C6-46EE-AE37-896F4CC27964}"/>
+                <a16:creationId xmlns:a16="http://schemas.microsoft.com/office/drawing/2014/main" id="{2929DB3A-EB26-4CFF-B196-ED3A6C80FACD}"/>
               </a:ext>
             </a:extLst>
           </p:cNvPr>
@@ -9741,7 +9741,7 @@
           <p:cNvPr id="10" name="">
             <a:extLst xmlns:a="http://schemas.openxmlformats.org/drawingml/2006/main">
               <a:ext uri="{FF2B5EF4-FFF2-40B4-BE49-F238E27FC236}">
-                <a16:creationId xmlns:a16="http://schemas.microsoft.com/office/drawing/2014/main" id="{29DD3981-2426-4CA0-9229-E102D253B57B}"/>
+                <a16:creationId xmlns:a16="http://schemas.microsoft.com/office/drawing/2014/main" id="{B107E460-DF76-403D-8404-9CDD890561C6}"/>
               </a:ext>
             </a:extLst>
           </p:cNvPr>
@@ -9772,7 +9772,7 @@
           <p:cNvPr id="11" name="02">
             <a:extLst xmlns:a="http://schemas.openxmlformats.org/drawingml/2006/main">
               <a:ext uri="{FF2B5EF4-FFF2-40B4-BE49-F238E27FC236}">
-                <a16:creationId xmlns:a16="http://schemas.microsoft.com/office/drawing/2014/main" id="{09DD834B-E223-4B44-948C-84CC22D2F3E9}"/>
+                <a16:creationId xmlns:a16="http://schemas.microsoft.com/office/drawing/2014/main" id="{A09BF9A6-C3D3-4E28-BA4A-10207312A040}"/>
               </a:ext>
             </a:extLst>
           </p:cNvPr>
@@ -9845,7 +9845,7 @@
           <p:cNvPr id="12" name="Legitimate large consumer payment">
             <a:extLst xmlns:a="http://schemas.openxmlformats.org/drawingml/2006/main">
               <a:ext uri="{FF2B5EF4-FFF2-40B4-BE49-F238E27FC236}">
-                <a16:creationId xmlns:a16="http://schemas.microsoft.com/office/drawing/2014/main" id="{3660F919-D364-4703-B5F5-64BC20FD4E19}"/>
+                <a16:creationId xmlns:a16="http://schemas.microsoft.com/office/drawing/2014/main" id="{77B29F8F-1678-4DAB-B742-F3DFA9421923}"/>
               </a:ext>
             </a:extLst>
           </p:cNvPr>
@@ -9918,7 +9918,7 @@
           <p:cNvPr id="13" name="VERIFY">
             <a:extLst xmlns:a="http://schemas.openxmlformats.org/drawingml/2006/main">
               <a:ext uri="{FF2B5EF4-FFF2-40B4-BE49-F238E27FC236}">
-                <a16:creationId xmlns:a16="http://schemas.microsoft.com/office/drawing/2014/main" id="{914326BF-CD7A-4957-9290-D9FC82A892CB}"/>
+                <a16:creationId xmlns:a16="http://schemas.microsoft.com/office/drawing/2014/main" id="{10D5DDE5-C2CB-4C27-8C12-40EB63FB8124}"/>
               </a:ext>
             </a:extLst>
           </p:cNvPr>
@@ -9991,7 +9991,7 @@
           <p:cNvPr id="14" name="">
             <a:extLst xmlns:a="http://schemas.openxmlformats.org/drawingml/2006/main">
               <a:ext uri="{FF2B5EF4-FFF2-40B4-BE49-F238E27FC236}">
-                <a16:creationId xmlns:a16="http://schemas.microsoft.com/office/drawing/2014/main" id="{9565A66E-35A5-4A7C-8A37-22D324737ED0}"/>
+                <a16:creationId xmlns:a16="http://schemas.microsoft.com/office/drawing/2014/main" id="{5AAEAB77-DC02-4F42-B1EB-D3C93347EBF0}"/>
               </a:ext>
             </a:extLst>
           </p:cNvPr>
@@ -10022,7 +10022,7 @@
           <p:cNvPr id="15" name="03">
             <a:extLst xmlns:a="http://schemas.openxmlformats.org/drawingml/2006/main">
               <a:ext uri="{FF2B5EF4-FFF2-40B4-BE49-F238E27FC236}">
-                <a16:creationId xmlns:a16="http://schemas.microsoft.com/office/drawing/2014/main" id="{674119EE-C49B-4ED5-994E-F0E0CC7B7E5B}"/>
+                <a16:creationId xmlns:a16="http://schemas.microsoft.com/office/drawing/2014/main" id="{ADEE0CC2-F9BD-4BD5-B2A9-04FF0C523D97}"/>
               </a:ext>
             </a:extLst>
           </p:cNvPr>
@@ -10095,7 +10095,7 @@
           <p:cNvPr id="16" name="Urgent, ambiguous family request">
             <a:extLst xmlns:a="http://schemas.openxmlformats.org/drawingml/2006/main">
               <a:ext uri="{FF2B5EF4-FFF2-40B4-BE49-F238E27FC236}">
-                <a16:creationId xmlns:a16="http://schemas.microsoft.com/office/drawing/2014/main" id="{2ABD190C-6B83-468A-8893-91B64AAF8DE5}"/>
+                <a16:creationId xmlns:a16="http://schemas.microsoft.com/office/drawing/2014/main" id="{32183C97-6AA0-4DD5-A2E6-80CAFFA04E4A}"/>
               </a:ext>
             </a:extLst>
           </p:cNvPr>
@@ -10168,7 +10168,7 @@
           <p:cNvPr id="17" name="VERIFY">
             <a:extLst xmlns:a="http://schemas.openxmlformats.org/drawingml/2006/main">
               <a:ext uri="{FF2B5EF4-FFF2-40B4-BE49-F238E27FC236}">
-                <a16:creationId xmlns:a16="http://schemas.microsoft.com/office/drawing/2014/main" id="{2BDBF010-6F55-440A-8DEB-AA264FA57374}"/>
+                <a16:creationId xmlns:a16="http://schemas.microsoft.com/office/drawing/2014/main" id="{EBA60CDE-0539-4D12-8CEA-71EDD76B4BAE}"/>
               </a:ext>
             </a:extLst>
           </p:cNvPr>
@@ -10241,7 +10241,7 @@
           <p:cNvPr id="18" name="">
             <a:extLst xmlns:a="http://schemas.openxmlformats.org/drawingml/2006/main">
               <a:ext uri="{FF2B5EF4-FFF2-40B4-BE49-F238E27FC236}">
-                <a16:creationId xmlns:a16="http://schemas.microsoft.com/office/drawing/2014/main" id="{00125AC1-0660-4DEE-B989-9EBB2FC71A0B}"/>
+                <a16:creationId xmlns:a16="http://schemas.microsoft.com/office/drawing/2014/main" id="{DF22DED8-BB4B-4636-88A9-2D45BD5C0FCB}"/>
               </a:ext>
             </a:extLst>
           </p:cNvPr>
@@ -10272,7 +10272,7 @@
           <p:cNvPr id="19" name="04">
             <a:extLst xmlns:a="http://schemas.openxmlformats.org/drawingml/2006/main">
               <a:ext uri="{FF2B5EF4-FFF2-40B4-BE49-F238E27FC236}">
-                <a16:creationId xmlns:a16="http://schemas.microsoft.com/office/drawing/2014/main" id="{B35E526A-C67C-4EBC-97B0-63000FB2FE47}"/>
+                <a16:creationId xmlns:a16="http://schemas.microsoft.com/office/drawing/2014/main" id="{1C4F0C48-32E9-46B2-A161-C9967264FE5F}"/>
               </a:ext>
             </a:extLst>
           </p:cNvPr>
@@ -10345,7 +10345,7 @@
           <p:cNvPr id="20" name="Invoice with changed vendor account">
             <a:extLst xmlns:a="http://schemas.openxmlformats.org/drawingml/2006/main">
               <a:ext uri="{FF2B5EF4-FFF2-40B4-BE49-F238E27FC236}">
-                <a16:creationId xmlns:a16="http://schemas.microsoft.com/office/drawing/2014/main" id="{F57B3C17-13B1-4461-A541-AF3B831FE6C6}"/>
+                <a16:creationId xmlns:a16="http://schemas.microsoft.com/office/drawing/2014/main" id="{8E5860E5-4BF8-4428-A2AB-F5F5CAEDA6D3}"/>
               </a:ext>
             </a:extLst>
           </p:cNvPr>
@@ -10418,7 +10418,7 @@
           <p:cNvPr id="21" name="REVIEW">
             <a:extLst xmlns:a="http://schemas.openxmlformats.org/drawingml/2006/main">
               <a:ext uri="{FF2B5EF4-FFF2-40B4-BE49-F238E27FC236}">
-                <a16:creationId xmlns:a16="http://schemas.microsoft.com/office/drawing/2014/main" id="{3381D9C4-F669-40F6-91AD-FB6AAE2DE729}"/>
+                <a16:creationId xmlns:a16="http://schemas.microsoft.com/office/drawing/2014/main" id="{5CBA0D0D-8AF6-4799-AB80-3FCC2063924A}"/>
               </a:ext>
             </a:extLst>
           </p:cNvPr>
@@ -10491,7 +10491,7 @@
           <p:cNvPr id="22" name="">
             <a:extLst xmlns:a="http://schemas.openxmlformats.org/drawingml/2006/main">
               <a:ext uri="{FF2B5EF4-FFF2-40B4-BE49-F238E27FC236}">
-                <a16:creationId xmlns:a16="http://schemas.microsoft.com/office/drawing/2014/main" id="{54DA98E2-E51F-40DB-A36E-14A4CDE6595C}"/>
+                <a16:creationId xmlns:a16="http://schemas.microsoft.com/office/drawing/2014/main" id="{4EA61372-2627-4B3A-8785-28BF27DC86EF}"/>
               </a:ext>
             </a:extLst>
           </p:cNvPr>
@@ -10522,7 +10522,7 @@
           <p:cNvPr id="23" name="05">
             <a:extLst xmlns:a="http://schemas.openxmlformats.org/drawingml/2006/main">
               <a:ext uri="{FF2B5EF4-FFF2-40B4-BE49-F238E27FC236}">
-                <a16:creationId xmlns:a16="http://schemas.microsoft.com/office/drawing/2014/main" id="{C1FB8941-6ABF-4D2A-957C-2D3A44DB2C16}"/>
+                <a16:creationId xmlns:a16="http://schemas.microsoft.com/office/drawing/2014/main" id="{629870B3-D405-43C9-BB15-7F5A346800CB}"/>
               </a:ext>
             </a:extLst>
           </p:cNvPr>
@@ -10595,7 +10595,7 @@
           <p:cNvPr id="24" name="Repeat invoice, matching account">
             <a:extLst xmlns:a="http://schemas.openxmlformats.org/drawingml/2006/main">
               <a:ext uri="{FF2B5EF4-FFF2-40B4-BE49-F238E27FC236}">
-                <a16:creationId xmlns:a16="http://schemas.microsoft.com/office/drawing/2014/main" id="{D8AC6165-E2CD-4A2B-8FF5-13183F077D0F}"/>
+                <a16:creationId xmlns:a16="http://schemas.microsoft.com/office/drawing/2014/main" id="{467BC5D9-6E51-4375-84A1-0BC6B6D7388E}"/>
               </a:ext>
             </a:extLst>
           </p:cNvPr>
@@ -10668,7 +10668,7 @@
           <p:cNvPr id="25" name="CONTINUE">
             <a:extLst xmlns:a="http://schemas.openxmlformats.org/drawingml/2006/main">
               <a:ext uri="{FF2B5EF4-FFF2-40B4-BE49-F238E27FC236}">
-                <a16:creationId xmlns:a16="http://schemas.microsoft.com/office/drawing/2014/main" id="{60C54C25-A57A-46A5-A52B-70019F58BB58}"/>
+                <a16:creationId xmlns:a16="http://schemas.microsoft.com/office/drawing/2014/main" id="{0F349258-DBEA-40C3-A799-9F8554D86440}"/>
               </a:ext>
             </a:extLst>
           </p:cNvPr>
@@ -10741,7 +10741,7 @@
           <p:cNvPr id="26" name="">
             <a:extLst xmlns:a="http://schemas.openxmlformats.org/drawingml/2006/main">
               <a:ext uri="{FF2B5EF4-FFF2-40B4-BE49-F238E27FC236}">
-                <a16:creationId xmlns:a16="http://schemas.microsoft.com/office/drawing/2014/main" id="{49ADDA5E-84DB-4E7A-B54A-B59D9B60051D}"/>
+                <a16:creationId xmlns:a16="http://schemas.microsoft.com/office/drawing/2014/main" id="{30FDA177-3A4E-4757-9FEF-AA7AD39D91D5}"/>
               </a:ext>
             </a:extLst>
           </p:cNvPr>
@@ -10772,7 +10772,7 @@
           <p:cNvPr id="27" name="06">
             <a:extLst xmlns:a="http://schemas.openxmlformats.org/drawingml/2006/main">
               <a:ext uri="{FF2B5EF4-FFF2-40B4-BE49-F238E27FC236}">
-                <a16:creationId xmlns:a16="http://schemas.microsoft.com/office/drawing/2014/main" id="{A315594E-281D-454F-8249-7777E9D13072}"/>
+                <a16:creationId xmlns:a16="http://schemas.microsoft.com/office/drawing/2014/main" id="{7A5C9A8C-0BE6-4264-9A57-1EA568196DD2}"/>
               </a:ext>
             </a:extLst>
           </p:cNvPr>
@@ -10845,7 +10845,7 @@
           <p:cNvPr id="28" name="Context provider timeout">
             <a:extLst xmlns:a="http://schemas.openxmlformats.org/drawingml/2006/main">
               <a:ext uri="{FF2B5EF4-FFF2-40B4-BE49-F238E27FC236}">
-                <a16:creationId xmlns:a16="http://schemas.microsoft.com/office/drawing/2014/main" id="{07EA7341-32E6-4120-BAF0-97FECDE8E65C}"/>
+                <a16:creationId xmlns:a16="http://schemas.microsoft.com/office/drawing/2014/main" id="{29619B92-DB75-44F2-98E2-B4AB020E7A94}"/>
               </a:ext>
             </a:extLst>
           </p:cNvPr>
@@ -10918,7 +10918,7 @@
           <p:cNvPr id="29" name="VERIFY">
             <a:extLst xmlns:a="http://schemas.openxmlformats.org/drawingml/2006/main">
               <a:ext uri="{FF2B5EF4-FFF2-40B4-BE49-F238E27FC236}">
-                <a16:creationId xmlns:a16="http://schemas.microsoft.com/office/drawing/2014/main" id="{167113CE-6A2D-49C5-8995-BDD63833D9C7}"/>
+                <a16:creationId xmlns:a16="http://schemas.microsoft.com/office/drawing/2014/main" id="{78279264-32EF-4630-B2EA-3AA52065CAEB}"/>
               </a:ext>
             </a:extLst>
           </p:cNvPr>
@@ -10991,7 +10991,7 @@
           <p:cNvPr id="30" name="">
             <a:extLst xmlns:a="http://schemas.openxmlformats.org/drawingml/2006/main">
               <a:ext uri="{FF2B5EF4-FFF2-40B4-BE49-F238E27FC236}">
-                <a16:creationId xmlns:a16="http://schemas.microsoft.com/office/drawing/2014/main" id="{823C59B5-CBCD-4090-9A8C-CBFE81A5A9F0}"/>
+                <a16:creationId xmlns:a16="http://schemas.microsoft.com/office/drawing/2014/main" id="{E1257FE1-F0A9-4FC6-817B-F73A2D4D61FB}"/>
               </a:ext>
             </a:extLst>
           </p:cNvPr>
@@ -11022,7 +11022,7 @@
           <p:cNvPr id="31" name="">
             <a:extLst xmlns:a="http://schemas.openxmlformats.org/drawingml/2006/main">
               <a:ext uri="{FF2B5EF4-FFF2-40B4-BE49-F238E27FC236}">
-                <a16:creationId xmlns:a16="http://schemas.microsoft.com/office/drawing/2014/main" id="{E56B55C5-D2BA-49E9-86EC-3925684F44CF}"/>
+                <a16:creationId xmlns:a16="http://schemas.microsoft.com/office/drawing/2014/main" id="{0D2A4D47-941A-4FD0-B405-10113160A40C}"/>
               </a:ext>
             </a:extLst>
           </p:cNvPr>
@@ -11050,7 +11050,7 @@
           <p:cNvPr id="32" name="EVALUATION PLAN">
             <a:extLst xmlns:a="http://schemas.openxmlformats.org/drawingml/2006/main">
               <a:ext uri="{FF2B5EF4-FFF2-40B4-BE49-F238E27FC236}">
-                <a16:creationId xmlns:a16="http://schemas.microsoft.com/office/drawing/2014/main" id="{4995AC86-A5D9-4DCA-B21A-705D7656FDDD}"/>
+                <a16:creationId xmlns:a16="http://schemas.microsoft.com/office/drawing/2014/main" id="{A9503C71-5A23-430B-96F7-F271011F9818}"/>
               </a:ext>
             </a:extLst>
           </p:cNvPr>
@@ -11123,7 +11123,7 @@
           <p:cNvPr id="33" name="40">
             <a:extLst xmlns:a="http://schemas.openxmlformats.org/drawingml/2006/main">
               <a:ext uri="{FF2B5EF4-FFF2-40B4-BE49-F238E27FC236}">
-                <a16:creationId xmlns:a16="http://schemas.microsoft.com/office/drawing/2014/main" id="{E94EA989-11FB-42E3-AD94-7526A3AA86D8}"/>
+                <a16:creationId xmlns:a16="http://schemas.microsoft.com/office/drawing/2014/main" id="{09839B4B-71E1-42AE-AA82-D98D4CAD5610}"/>
               </a:ext>
             </a:extLst>
           </p:cNvPr>
@@ -11196,7 +11196,7 @@
           <p:cNvPr id="34" name="synthetic examples">
             <a:extLst xmlns:a="http://schemas.openxmlformats.org/drawingml/2006/main">
               <a:ext uri="{FF2B5EF4-FFF2-40B4-BE49-F238E27FC236}">
-                <a16:creationId xmlns:a16="http://schemas.microsoft.com/office/drawing/2014/main" id="{B2940213-3F83-4050-89DF-E0A5B323C8EA}"/>
+                <a16:creationId xmlns:a16="http://schemas.microsoft.com/office/drawing/2014/main" id="{A7F0E76E-00CB-400E-A67D-E8AF91752D90}"/>
               </a:ext>
             </a:extLst>
           </p:cNvPr>
@@ -11269,7 +11269,7 @@
           <p:cNvPr id="35" name="20 development  /  20 held out">
             <a:extLst xmlns:a="http://schemas.openxmlformats.org/drawingml/2006/main">
               <a:ext uri="{FF2B5EF4-FFF2-40B4-BE49-F238E27FC236}">
-                <a16:creationId xmlns:a16="http://schemas.microsoft.com/office/drawing/2014/main" id="{297D15FD-2C15-4AEA-8260-86694A077E2E}"/>
+                <a16:creationId xmlns:a16="http://schemas.microsoft.com/office/drawing/2014/main" id="{F897A4C2-761D-49E1-B18A-4F8053C56A54}"/>
               </a:ext>
             </a:extLst>
           </p:cNvPr>
@@ -11342,7 +11342,7 @@
           <p:cNvPr id="36" name="">
             <a:extLst xmlns:a="http://schemas.openxmlformats.org/drawingml/2006/main">
               <a:ext uri="{FF2B5EF4-FFF2-40B4-BE49-F238E27FC236}">
-                <a16:creationId xmlns:a16="http://schemas.microsoft.com/office/drawing/2014/main" id="{91CD2114-AEF8-4EE8-9A77-BD7DF81364BC}"/>
+                <a16:creationId xmlns:a16="http://schemas.microsoft.com/office/drawing/2014/main" id="{64C58B33-D272-4CBB-A356-0BE29C7D5379}"/>
               </a:ext>
             </a:extLst>
           </p:cNvPr>
@@ -11373,7 +11373,7 @@
           <p:cNvPr id="37" name="Compare rules-only with the&#10;configured c">
             <a:extLst xmlns:a="http://schemas.openxmlformats.org/drawingml/2006/main">
               <a:ext uri="{FF2B5EF4-FFF2-40B4-BE49-F238E27FC236}">
-                <a16:creationId xmlns:a16="http://schemas.microsoft.com/office/drawing/2014/main" id="{A465DE95-4344-47FB-8D8F-595A8DE48B08}"/>
+                <a16:creationId xmlns:a16="http://schemas.microsoft.com/office/drawing/2014/main" id="{D2B3A892-D682-471E-AE8C-1CD5354D1BB8}"/>
               </a:ext>
             </a:extLst>
           </p:cNvPr>
@@ -11473,7 +11473,7 @@
           <p:cNvPr id="38" name="Report intervention recall, intervention">
             <a:extLst xmlns:a="http://schemas.openxmlformats.org/drawingml/2006/main">
               <a:ext uri="{FF2B5EF4-FFF2-40B4-BE49-F238E27FC236}">
-                <a16:creationId xmlns:a16="http://schemas.microsoft.com/office/drawing/2014/main" id="{97D817C8-E8A2-45C9-9524-4EB98B5C3B1A}"/>
+                <a16:creationId xmlns:a16="http://schemas.microsoft.com/office/drawing/2014/main" id="{BF449ED3-D052-4FDB-BED6-030C616AAD00}"/>
               </a:ext>
             </a:extLst>
           </p:cNvPr>
@@ -11546,7 +11546,7 @@
           <p:cNvPr id="39" name="">
             <a:extLst xmlns:a="http://schemas.openxmlformats.org/drawingml/2006/main">
               <a:ext uri="{FF2B5EF4-FFF2-40B4-BE49-F238E27FC236}">
-                <a16:creationId xmlns:a16="http://schemas.microsoft.com/office/drawing/2014/main" id="{8923AE74-2DEA-4D00-BC8D-E3D1FEB41736}"/>
+                <a16:creationId xmlns:a16="http://schemas.microsoft.com/office/drawing/2014/main" id="{9D72DC16-B382-48D7-A3DF-493C7F04F8D4}"/>
               </a:ext>
             </a:extLst>
           </p:cNvPr>
@@ -11577,7 +11577,7 @@
           <p:cNvPr id="40" name="Synthetic evaluation plan  /  No measure">
             <a:extLst xmlns:a="http://schemas.openxmlformats.org/drawingml/2006/main">
               <a:ext uri="{FF2B5EF4-FFF2-40B4-BE49-F238E27FC236}">
-                <a16:creationId xmlns:a16="http://schemas.microsoft.com/office/drawing/2014/main" id="{67C9AEA2-65B5-49E5-8BB9-FDC1794C9ECB}"/>
+                <a16:creationId xmlns:a16="http://schemas.microsoft.com/office/drawing/2014/main" id="{DE3D13C5-D0CC-4A2F-B561-5C5B30AC8294}"/>
               </a:ext>
             </a:extLst>
           </p:cNvPr>
@@ -11648,7 +11648,7 @@
     </p:spTree>
     <p:extLst>
       <p:ext uri="{BB962C8B-B14F-4D97-AF65-F5344CB8AC3E}">
-        <p14:creationId xmlns:p14="http://schemas.microsoft.com/office/powerpoint/2010/main" val="68969595"/>
+        <p14:creationId xmlns:p14="http://schemas.microsoft.com/office/powerpoint/2010/main" val="111447501"/>
       </p:ext>
     </p:extLst>
   </p:cSld>
@@ -11679,7 +11679,7 @@
           <p:cNvPr id="27" name="SCAMSHIELD  /  CONCEPT PITCH">
             <a:extLst xmlns:a="http://schemas.openxmlformats.org/drawingml/2006/main">
               <a:ext uri="{FF2B5EF4-FFF2-40B4-BE49-F238E27FC236}">
-                <a16:creationId xmlns:a16="http://schemas.microsoft.com/office/drawing/2014/main" id="{9B1AFB6E-6EA3-4BB9-8CEC-EE16A3F3ED8A}"/>
+                <a16:creationId xmlns:a16="http://schemas.microsoft.com/office/drawing/2014/main" id="{7D907610-2D01-4FE6-BCE2-A8FB6C3ED249}"/>
               </a:ext>
             </a:extLst>
           </p:cNvPr>
@@ -11752,7 +11752,7 @@
           <p:cNvPr id="2" name="06  /  06">
             <a:extLst xmlns:a="http://schemas.openxmlformats.org/drawingml/2006/main">
               <a:ext uri="{FF2B5EF4-FFF2-40B4-BE49-F238E27FC236}">
-                <a16:creationId xmlns:a16="http://schemas.microsoft.com/office/drawing/2014/main" id="{A3FFEDF6-CE29-4746-9623-D5F0368C1E16}"/>
+                <a16:creationId xmlns:a16="http://schemas.microsoft.com/office/drawing/2014/main" id="{BAF22366-8ED6-40BF-B64B-6A58585E6933}"/>
               </a:ext>
             </a:extLst>
           </p:cNvPr>
@@ -11825,7 +11825,7 @@
           <p:cNvPr id="3" name="">
             <a:extLst xmlns:a="http://schemas.openxmlformats.org/drawingml/2006/main">
               <a:ext uri="{FF2B5EF4-FFF2-40B4-BE49-F238E27FC236}">
-                <a16:creationId xmlns:a16="http://schemas.microsoft.com/office/drawing/2014/main" id="{FFDBB38A-CE6E-48EA-A1DC-0969300237E2}"/>
+                <a16:creationId xmlns:a16="http://schemas.microsoft.com/office/drawing/2014/main" id="{58CE8DE3-1619-457F-999D-7C5BC7AF12DA}"/>
               </a:ext>
             </a:extLst>
           </p:cNvPr>
@@ -11856,7 +11856,7 @@
           <p:cNvPr id="4" name="A focused prototype fits a 48–72 hour bu">
             <a:extLst xmlns:a="http://schemas.openxmlformats.org/drawingml/2006/main">
               <a:ext uri="{FF2B5EF4-FFF2-40B4-BE49-F238E27FC236}">
-                <a16:creationId xmlns:a16="http://schemas.microsoft.com/office/drawing/2014/main" id="{F6C1D755-8B3C-47CA-B888-B998AE46C40A}"/>
+                <a16:creationId xmlns:a16="http://schemas.microsoft.com/office/drawing/2014/main" id="{6A31A972-86F5-4413-812B-148A5108392B}"/>
               </a:ext>
             </a:extLst>
           </p:cNvPr>
@@ -11929,7 +11929,7 @@
           <p:cNvPr id="5" name="Deliver the two simulators and an audita">
             <a:extLst xmlns:a="http://schemas.openxmlformats.org/drawingml/2006/main">
               <a:ext uri="{FF2B5EF4-FFF2-40B4-BE49-F238E27FC236}">
-                <a16:creationId xmlns:a16="http://schemas.microsoft.com/office/drawing/2014/main" id="{5E8654E1-9E79-43EB-BA3F-FA5CA7C1D092}"/>
+                <a16:creationId xmlns:a16="http://schemas.microsoft.com/office/drawing/2014/main" id="{905C8D7E-82C1-4AC4-B81A-8920291699F0}"/>
               </a:ext>
             </a:extLst>
           </p:cNvPr>
@@ -12002,7 +12002,7 @@
           <p:cNvPr id="6" name="FIRST 48 HOURS">
             <a:extLst xmlns:a="http://schemas.openxmlformats.org/drawingml/2006/main">
               <a:ext uri="{FF2B5EF4-FFF2-40B4-BE49-F238E27FC236}">
-                <a16:creationId xmlns:a16="http://schemas.microsoft.com/office/drawing/2014/main" id="{523EFF6F-2FA1-40E4-BA36-3304BE096051}"/>
+                <a16:creationId xmlns:a16="http://schemas.microsoft.com/office/drawing/2014/main" id="{DF31059E-7AFF-4426-B388-2D6B307C85BF}"/>
               </a:ext>
             </a:extLst>
           </p:cNvPr>
@@ -12075,7 +12075,7 @@
           <p:cNvPr id="7" name="Contracts and fixtures">
             <a:extLst xmlns:a="http://schemas.openxmlformats.org/drawingml/2006/main">
               <a:ext uri="{FF2B5EF4-FFF2-40B4-BE49-F238E27FC236}">
-                <a16:creationId xmlns:a16="http://schemas.microsoft.com/office/drawing/2014/main" id="{CE11F6F8-4CD6-4E35-A6AE-C2E391CB8EBA}"/>
+                <a16:creationId xmlns:a16="http://schemas.microsoft.com/office/drawing/2014/main" id="{C0EA70F3-EEF6-4F69-B5C6-5813925DC323}"/>
               </a:ext>
             </a:extLst>
           </p:cNvPr>
@@ -12148,7 +12148,7 @@
           <p:cNvPr id="8" name="Two adapters, deterministic rules, polic">
             <a:extLst xmlns:a="http://schemas.openxmlformats.org/drawingml/2006/main">
               <a:ext uri="{FF2B5EF4-FFF2-40B4-BE49-F238E27FC236}">
-                <a16:creationId xmlns:a16="http://schemas.microsoft.com/office/drawing/2014/main" id="{F856D29C-4051-49D2-A583-A29ADFDEC83E}"/>
+                <a16:creationId xmlns:a16="http://schemas.microsoft.com/office/drawing/2014/main" id="{0C009DCB-52E4-4A4C-AED2-3ED24BD922EA}"/>
               </a:ext>
             </a:extLst>
           </p:cNvPr>
@@ -12221,7 +12221,7 @@
           <p:cNvPr id="9" name="">
             <a:extLst xmlns:a="http://schemas.openxmlformats.org/drawingml/2006/main">
               <a:ext uri="{FF2B5EF4-FFF2-40B4-BE49-F238E27FC236}">
-                <a16:creationId xmlns:a16="http://schemas.microsoft.com/office/drawing/2014/main" id="{49382A12-9341-42D7-B95E-267968572EA6}"/>
+                <a16:creationId xmlns:a16="http://schemas.microsoft.com/office/drawing/2014/main" id="{02654862-B218-445F-B072-EB9C2C47033C}"/>
               </a:ext>
             </a:extLst>
           </p:cNvPr>
@@ -12252,7 +12252,7 @@
           <p:cNvPr id="10" name="Simulators and investigation view">
             <a:extLst xmlns:a="http://schemas.openxmlformats.org/drawingml/2006/main">
               <a:ext uri="{FF2B5EF4-FFF2-40B4-BE49-F238E27FC236}">
-                <a16:creationId xmlns:a16="http://schemas.microsoft.com/office/drawing/2014/main" id="{DE451EC2-2768-4DB0-BBFB-381CBFA20107}"/>
+                <a16:creationId xmlns:a16="http://schemas.microsoft.com/office/drawing/2014/main" id="{7BFE67B9-2211-4BB3-B15D-28699AFB37E8}"/>
               </a:ext>
             </a:extLst>
           </p:cNvPr>
@@ -12325,7 +12325,7 @@
           <p:cNvPr id="11" name="Consumer transfer, invoice payment, case">
             <a:extLst xmlns:a="http://schemas.openxmlformats.org/drawingml/2006/main">
               <a:ext uri="{FF2B5EF4-FFF2-40B4-BE49-F238E27FC236}">
-                <a16:creationId xmlns:a16="http://schemas.microsoft.com/office/drawing/2014/main" id="{07B4BFC4-4DDB-4E10-B849-BA8B0A050754}"/>
+                <a16:creationId xmlns:a16="http://schemas.microsoft.com/office/drawing/2014/main" id="{6A1DE389-1EBD-470D-ABCF-CA4B31FB4E99}"/>
               </a:ext>
             </a:extLst>
           </p:cNvPr>
@@ -12398,7 +12398,7 @@
           <p:cNvPr id="12" name="">
             <a:extLst xmlns:a="http://schemas.openxmlformats.org/drawingml/2006/main">
               <a:ext uri="{FF2B5EF4-FFF2-40B4-BE49-F238E27FC236}">
-                <a16:creationId xmlns:a16="http://schemas.microsoft.com/office/drawing/2014/main" id="{4F3CB821-9716-4642-A2E9-F85B4C85CB85}"/>
+                <a16:creationId xmlns:a16="http://schemas.microsoft.com/office/drawing/2014/main" id="{9CCFBFD4-C742-4567-8428-8C1CFB4552E8}"/>
               </a:ext>
             </a:extLst>
           </p:cNvPr>
@@ -12426,10 +12426,10 @@
       </p:sp>
       <p:sp>
         <p:nvSpPr>
-          <p:cNvPr id="13" name="Provider integrations">
-            <a:extLst xmlns:a="http://schemas.openxmlformats.org/drawingml/2006/main">
-              <a:ext uri="{FF2B5EF4-FFF2-40B4-BE49-F238E27FC236}">
-                <a16:creationId xmlns:a16="http://schemas.microsoft.com/office/drawing/2014/main" id="{C88DE107-7435-423A-8BEF-85AEB0E8CD30}"/>
+          <p:cNvPr id="13" name="Local setup">
+            <a:extLst xmlns:a="http://schemas.openxmlformats.org/drawingml/2006/main">
+              <a:ext uri="{FF2B5EF4-FFF2-40B4-BE49-F238E27FC236}">
+                <a16:creationId xmlns:a16="http://schemas.microsoft.com/office/drawing/2014/main" id="{FE5C0624-892D-422B-A753-9C2996E62398}"/>
               </a:ext>
             </a:extLst>
           </p:cNvPr>
@@ -12492,17 +12492,17 @@
                 <a:ea typeface="Avenir Next"/>
                 <a:cs typeface="Avenir Next"/>
               </a:rPr>
-              <a:t>Provider integrations</a:t>
+              <a:t>Local setup</a:t>
             </a:r>
           </a:p>
         </p:txBody>
       </p:sp>
       <p:sp>
         <p:nvSpPr>
-          <p:cNvPr id="14" name="Configure Gemini classification and expl">
-            <a:extLst xmlns:a="http://schemas.openxmlformats.org/drawingml/2006/main">
-              <a:ext uri="{FF2B5EF4-FFF2-40B4-BE49-F238E27FC236}">
-                <a16:creationId xmlns:a16="http://schemas.microsoft.com/office/drawing/2014/main" id="{423F497B-9596-4913-8A2E-F93FCF69B727}"/>
+          <p:cNvPr id="14" name="Gemini Developer API free tier for Flash">
+            <a:extLst xmlns:a="http://schemas.openxmlformats.org/drawingml/2006/main">
+              <a:ext uri="{FF2B5EF4-FFF2-40B4-BE49-F238E27FC236}">
+                <a16:creationId xmlns:a16="http://schemas.microsoft.com/office/drawing/2014/main" id="{73158B31-6F18-45B0-BF51-BC01B6260594}"/>
               </a:ext>
             </a:extLst>
           </p:cNvPr>
@@ -12514,7 +12514,608 @@
         <p:spPr>
           <a:xfrm xmlns:a="http://schemas.openxmlformats.org/drawingml/2006/main">
             <a:off x="685800" y="5638800"/>
-            <a:ext cx="4524375" cy="400050"/>
+            <a:ext cx="4762500" cy="457200"/>
+          </a:xfrm>
+          <a:prstGeom xmlns:a="http://schemas.openxmlformats.org/drawingml/2006/main" prst="rect">
+            <a:avLst/>
+          </a:prstGeom>
+          <a:noFill xmlns:a="http://schemas.openxmlformats.org/drawingml/2006/main"/>
+          <a:ln xmlns:a="http://schemas.openxmlformats.org/drawingml/2006/main" w="0">
+            <a:noFill/>
+            <a:prstDash val="solid"/>
+          </a:ln>
+        </p:spPr>
+        <p:txBody>
+          <a:bodyPr xmlns:a="http://schemas.openxmlformats.org/drawingml/2006/main" wrap="square" lIns="0" tIns="0" rIns="0" bIns="0" anchor="t">
+            <a:normAutofit fontScale="100000"/>
+          </a:bodyPr>
+          <a:lstStyle xmlns:a="http://schemas.openxmlformats.org/drawingml/2006/main">
+            <a:defPPr algn="l">
+              <a:defRPr sz="975" b="0">
+                <a:solidFill>
+                  <a:srgbClr val="59675F"/>
+                </a:solidFill>
+                <a:latin typeface="Avenir Next"/>
+                <a:ea typeface="Avenir Next"/>
+                <a:cs typeface="Avenir Next"/>
+              </a:defRPr>
+            </a:defPPr>
+          </a:lstStyle>
+          <a:p xmlns:a="http://schemas.openxmlformats.org/drawingml/2006/main">
+            <a:pPr algn="l">
+              <a:lnSpc>
+                <a:spcPct val="114000"/>
+              </a:lnSpc>
+              <a:buNone/>
+              <a:defRPr sz="975" b="0">
+                <a:solidFill>
+                  <a:srgbClr val="59675F"/>
+                </a:solidFill>
+                <a:latin typeface="Avenir Next"/>
+                <a:ea typeface="Avenir Next"/>
+                <a:cs typeface="Avenir Next"/>
+              </a:defRPr>
+            </a:pPr>
+            <a:r>
+              <a:rPr sz="975" b="0">
+                <a:solidFill>
+                  <a:srgbClr val="59675F"/>
+                </a:solidFill>
+                <a:latin typeface="Avenir Next"/>
+                <a:ea typeface="Avenir Next"/>
+                <a:cs typeface="Avenir Next"/>
+              </a:rPr>
+              <a:t>Gemini Developer API free tier for Flash or Flash-Lite. Rate limits apply; use synthetic inputs.</a:t>
+            </a:r>
+          </a:p>
+        </p:txBody>
+      </p:sp>
+      <p:sp>
+        <p:nvSpPr>
+          <p:cNvPr id="15" name="">
+            <a:extLst xmlns:a="http://schemas.openxmlformats.org/drawingml/2006/main">
+              <a:ext uri="{FF2B5EF4-FFF2-40B4-BE49-F238E27FC236}">
+                <a16:creationId xmlns:a16="http://schemas.microsoft.com/office/drawing/2014/main" id="{A9AC26E3-8E5E-4005-BF9C-555888201F8E}"/>
+              </a:ext>
+            </a:extLst>
+          </p:cNvPr>
+          <p:cNvSpPr>
+            <a:spLocks xmlns:a="http://schemas.openxmlformats.org/drawingml/2006/main" noGrp="1"/>
+          </p:cNvSpPr>
+          <p:nvPr/>
+        </p:nvSpPr>
+        <p:spPr>
+          <a:xfrm xmlns:a="http://schemas.openxmlformats.org/drawingml/2006/main">
+            <a:off x="6172200" y="2324100"/>
+            <a:ext cx="9525" cy="0"/>
+          </a:xfrm>
+          <a:prstGeom xmlns:a="http://schemas.openxmlformats.org/drawingml/2006/main" prst="rect">
+            <a:avLst/>
+          </a:prstGeom>
+          <a:ln xmlns:a="http://schemas.openxmlformats.org/drawingml/2006/main" w="0">
+            <a:noFill/>
+            <a:prstDash val="solid"/>
+          </a:ln>
+        </p:spPr>
+      </p:sp>
+      <p:sp>
+        <p:nvSpPr>
+          <p:cNvPr id="16" name="NEXT 24 HOURS  /  BUFFER">
+            <a:extLst xmlns:a="http://schemas.openxmlformats.org/drawingml/2006/main">
+              <a:ext uri="{FF2B5EF4-FFF2-40B4-BE49-F238E27FC236}">
+                <a16:creationId xmlns:a16="http://schemas.microsoft.com/office/drawing/2014/main" id="{C2B565AF-29AE-4FB5-8151-3ED71960CD62}"/>
+              </a:ext>
+            </a:extLst>
+          </p:cNvPr>
+          <p:cNvSpPr>
+            <a:spLocks xmlns:a="http://schemas.openxmlformats.org/drawingml/2006/main" noGrp="1"/>
+          </p:cNvSpPr>
+          <p:nvPr/>
+        </p:nvSpPr>
+        <p:spPr>
+          <a:xfrm xmlns:a="http://schemas.openxmlformats.org/drawingml/2006/main">
+            <a:off x="6686550" y="2324100"/>
+            <a:ext cx="3810000" cy="190500"/>
+          </a:xfrm>
+          <a:prstGeom xmlns:a="http://schemas.openxmlformats.org/drawingml/2006/main" prst="rect">
+            <a:avLst/>
+          </a:prstGeom>
+          <a:noFill xmlns:a="http://schemas.openxmlformats.org/drawingml/2006/main"/>
+          <a:ln xmlns:a="http://schemas.openxmlformats.org/drawingml/2006/main" w="0">
+            <a:noFill/>
+            <a:prstDash val="solid"/>
+          </a:ln>
+        </p:spPr>
+        <p:txBody>
+          <a:bodyPr xmlns:a="http://schemas.openxmlformats.org/drawingml/2006/main" wrap="square" lIns="0" tIns="0" rIns="0" bIns="0" anchor="t">
+            <a:normAutofit fontScale="100000"/>
+          </a:bodyPr>
+          <a:lstStyle xmlns:a="http://schemas.openxmlformats.org/drawingml/2006/main">
+            <a:defPPr algn="l">
+              <a:defRPr sz="900" b="1">
+                <a:solidFill>
+                  <a:srgbClr val="BE7839"/>
+                </a:solidFill>
+                <a:latin typeface="Avenir Next"/>
+                <a:ea typeface="Avenir Next"/>
+                <a:cs typeface="Avenir Next"/>
+              </a:defRPr>
+            </a:defPPr>
+          </a:lstStyle>
+          <a:p xmlns:a="http://schemas.openxmlformats.org/drawingml/2006/main">
+            <a:pPr algn="l">
+              <a:lnSpc>
+                <a:spcPct val="106000"/>
+              </a:lnSpc>
+              <a:buNone/>
+              <a:defRPr sz="900" b="1">
+                <a:solidFill>
+                  <a:srgbClr val="BE7839"/>
+                </a:solidFill>
+                <a:latin typeface="Avenir Next"/>
+                <a:ea typeface="Avenir Next"/>
+                <a:cs typeface="Avenir Next"/>
+              </a:defRPr>
+            </a:pPr>
+            <a:r>
+              <a:rPr sz="900" b="1">
+                <a:solidFill>
+                  <a:srgbClr val="BE7839"/>
+                </a:solidFill>
+                <a:latin typeface="Avenir Next"/>
+                <a:ea typeface="Avenir Next"/>
+                <a:cs typeface="Avenir Next"/>
+              </a:rPr>
+              <a:t>NEXT 24 HOURS  /  BUFFER</a:t>
+            </a:r>
+          </a:p>
+        </p:txBody>
+      </p:sp>
+      <p:sp>
+        <p:nvSpPr>
+          <p:cNvPr id="17" name="Held-out evaluation">
+            <a:extLst xmlns:a="http://schemas.openxmlformats.org/drawingml/2006/main">
+              <a:ext uri="{FF2B5EF4-FFF2-40B4-BE49-F238E27FC236}">
+                <a16:creationId xmlns:a16="http://schemas.microsoft.com/office/drawing/2014/main" id="{6F159C25-79ED-4569-949B-3E1F4CD4E100}"/>
+              </a:ext>
+            </a:extLst>
+          </p:cNvPr>
+          <p:cNvSpPr>
+            <a:spLocks xmlns:a="http://schemas.openxmlformats.org/drawingml/2006/main" noGrp="1"/>
+          </p:cNvSpPr>
+          <p:nvPr/>
+        </p:nvSpPr>
+        <p:spPr>
+          <a:xfrm xmlns:a="http://schemas.openxmlformats.org/drawingml/2006/main">
+            <a:off x="6686550" y="2686050"/>
+            <a:ext cx="4095750" cy="276225"/>
+          </a:xfrm>
+          <a:prstGeom xmlns:a="http://schemas.openxmlformats.org/drawingml/2006/main" prst="rect">
+            <a:avLst/>
+          </a:prstGeom>
+          <a:noFill xmlns:a="http://schemas.openxmlformats.org/drawingml/2006/main"/>
+          <a:ln xmlns:a="http://schemas.openxmlformats.org/drawingml/2006/main" w="0">
+            <a:noFill/>
+            <a:prstDash val="solid"/>
+          </a:ln>
+        </p:spPr>
+        <p:txBody>
+          <a:bodyPr xmlns:a="http://schemas.openxmlformats.org/drawingml/2006/main" wrap="square" lIns="0" tIns="0" rIns="0" bIns="0" anchor="t">
+            <a:normAutofit fontScale="100000"/>
+          </a:bodyPr>
+          <a:lstStyle xmlns:a="http://schemas.openxmlformats.org/drawingml/2006/main">
+            <a:defPPr algn="l">
+              <a:defRPr sz="1650" b="1">
+                <a:solidFill>
+                  <a:srgbClr val="172821"/>
+                </a:solidFill>
+                <a:latin typeface="Avenir Next"/>
+                <a:ea typeface="Avenir Next"/>
+                <a:cs typeface="Avenir Next"/>
+              </a:defRPr>
+            </a:defPPr>
+          </a:lstStyle>
+          <a:p xmlns:a="http://schemas.openxmlformats.org/drawingml/2006/main">
+            <a:pPr algn="l">
+              <a:lnSpc>
+                <a:spcPct val="106000"/>
+              </a:lnSpc>
+              <a:buNone/>
+              <a:defRPr sz="1650" b="1">
+                <a:solidFill>
+                  <a:srgbClr val="172821"/>
+                </a:solidFill>
+                <a:latin typeface="Avenir Next"/>
+                <a:ea typeface="Avenir Next"/>
+                <a:cs typeface="Avenir Next"/>
+              </a:defRPr>
+            </a:pPr>
+            <a:r>
+              <a:rPr sz="1650" b="1">
+                <a:solidFill>
+                  <a:srgbClr val="172821"/>
+                </a:solidFill>
+                <a:latin typeface="Avenir Next"/>
+                <a:ea typeface="Avenir Next"/>
+                <a:cs typeface="Avenir Next"/>
+              </a:rPr>
+              <a:t>Held-out evaluation</a:t>
+            </a:r>
+          </a:p>
+        </p:txBody>
+      </p:sp>
+      <p:sp>
+        <p:nvSpPr>
+          <p:cNvPr id="18" name="Compare policy behavior, record failures">
+            <a:extLst xmlns:a="http://schemas.openxmlformats.org/drawingml/2006/main">
+              <a:ext uri="{FF2B5EF4-FFF2-40B4-BE49-F238E27FC236}">
+                <a16:creationId xmlns:a16="http://schemas.microsoft.com/office/drawing/2014/main" id="{5EBA26C1-56DF-449D-B876-D2EFFFEE3DFF}"/>
+              </a:ext>
+            </a:extLst>
+          </p:cNvPr>
+          <p:cNvSpPr>
+            <a:spLocks xmlns:a="http://schemas.openxmlformats.org/drawingml/2006/main" noGrp="1"/>
+          </p:cNvSpPr>
+          <p:nvPr/>
+        </p:nvSpPr>
+        <p:spPr>
+          <a:xfrm xmlns:a="http://schemas.openxmlformats.org/drawingml/2006/main">
+            <a:off x="6686550" y="3067050"/>
+            <a:ext cx="4133850" cy="495300"/>
+          </a:xfrm>
+          <a:prstGeom xmlns:a="http://schemas.openxmlformats.org/drawingml/2006/main" prst="rect">
+            <a:avLst/>
+          </a:prstGeom>
+          <a:noFill xmlns:a="http://schemas.openxmlformats.org/drawingml/2006/main"/>
+          <a:ln xmlns:a="http://schemas.openxmlformats.org/drawingml/2006/main" w="0">
+            <a:noFill/>
+            <a:prstDash val="solid"/>
+          </a:ln>
+        </p:spPr>
+        <p:txBody>
+          <a:bodyPr xmlns:a="http://schemas.openxmlformats.org/drawingml/2006/main" wrap="square" lIns="0" tIns="0" rIns="0" bIns="0" anchor="t">
+            <a:normAutofit fontScale="100000"/>
+          </a:bodyPr>
+          <a:lstStyle xmlns:a="http://schemas.openxmlformats.org/drawingml/2006/main">
+            <a:defPPr algn="l">
+              <a:defRPr sz="1200" b="0">
+                <a:solidFill>
+                  <a:srgbClr val="59675F"/>
+                </a:solidFill>
+                <a:latin typeface="Avenir Next"/>
+                <a:ea typeface="Avenir Next"/>
+                <a:cs typeface="Avenir Next"/>
+              </a:defRPr>
+            </a:defPPr>
+          </a:lstStyle>
+          <a:p xmlns:a="http://schemas.openxmlformats.org/drawingml/2006/main">
+            <a:pPr algn="l">
+              <a:lnSpc>
+                <a:spcPct val="106000"/>
+              </a:lnSpc>
+              <a:buNone/>
+              <a:defRPr sz="1200" b="0">
+                <a:solidFill>
+                  <a:srgbClr val="59675F"/>
+                </a:solidFill>
+                <a:latin typeface="Avenir Next"/>
+                <a:ea typeface="Avenir Next"/>
+                <a:cs typeface="Avenir Next"/>
+              </a:defRPr>
+            </a:pPr>
+            <a:r>
+              <a:rPr sz="1200" b="0">
+                <a:solidFill>
+                  <a:srgbClr val="59675F"/>
+                </a:solidFill>
+                <a:latin typeface="Avenir Next"/>
+                <a:ea typeface="Avenir Next"/>
+                <a:cs typeface="Avenir Next"/>
+              </a:rPr>
+              <a:t>Compare policy behavior, record failures and measure latency by stage.</a:t>
+            </a:r>
+          </a:p>
+        </p:txBody>
+      </p:sp>
+      <p:sp>
+        <p:nvSpPr>
+          <p:cNvPr id="19" name="">
+            <a:extLst xmlns:a="http://schemas.openxmlformats.org/drawingml/2006/main">
+              <a:ext uri="{FF2B5EF4-FFF2-40B4-BE49-F238E27FC236}">
+                <a16:creationId xmlns:a16="http://schemas.microsoft.com/office/drawing/2014/main" id="{A1508E07-BE27-4A1B-A5F4-8417618DD013}"/>
+              </a:ext>
+            </a:extLst>
+          </p:cNvPr>
+          <p:cNvSpPr>
+            <a:spLocks xmlns:a="http://schemas.openxmlformats.org/drawingml/2006/main" noGrp="1"/>
+          </p:cNvSpPr>
+          <p:nvPr/>
+        </p:nvSpPr>
+        <p:spPr>
+          <a:xfrm xmlns:a="http://schemas.openxmlformats.org/drawingml/2006/main">
+            <a:off x="6686550" y="3771900"/>
+            <a:ext cx="4152900" cy="9525"/>
+          </a:xfrm>
+          <a:prstGeom xmlns:a="http://schemas.openxmlformats.org/drawingml/2006/main" prst="rect">
+            <a:avLst/>
+          </a:prstGeom>
+          <a:solidFill xmlns:a="http://schemas.openxmlformats.org/drawingml/2006/main">
+            <a:srgbClr val="C9D1C8"/>
+          </a:solidFill>
+          <a:ln xmlns:a="http://schemas.openxmlformats.org/drawingml/2006/main" w="0">
+            <a:noFill/>
+            <a:prstDash val="solid"/>
+          </a:ln>
+        </p:spPr>
+      </p:sp>
+      <p:sp>
+        <p:nvSpPr>
+          <p:cNvPr id="20" name="Cloud readiness check">
+            <a:extLst xmlns:a="http://schemas.openxmlformats.org/drawingml/2006/main">
+              <a:ext uri="{FF2B5EF4-FFF2-40B4-BE49-F238E27FC236}">
+                <a16:creationId xmlns:a16="http://schemas.microsoft.com/office/drawing/2014/main" id="{8AD41918-2E60-48F0-97D4-5396993B6674}"/>
+              </a:ext>
+            </a:extLst>
+          </p:cNvPr>
+          <p:cNvSpPr>
+            <a:spLocks xmlns:a="http://schemas.openxmlformats.org/drawingml/2006/main" noGrp="1"/>
+          </p:cNvSpPr>
+          <p:nvPr/>
+        </p:nvSpPr>
+        <p:spPr>
+          <a:xfrm xmlns:a="http://schemas.openxmlformats.org/drawingml/2006/main">
+            <a:off x="6686550" y="3981450"/>
+            <a:ext cx="4095750" cy="276225"/>
+          </a:xfrm>
+          <a:prstGeom xmlns:a="http://schemas.openxmlformats.org/drawingml/2006/main" prst="rect">
+            <a:avLst/>
+          </a:prstGeom>
+          <a:noFill xmlns:a="http://schemas.openxmlformats.org/drawingml/2006/main"/>
+          <a:ln xmlns:a="http://schemas.openxmlformats.org/drawingml/2006/main" w="0">
+            <a:noFill/>
+            <a:prstDash val="solid"/>
+          </a:ln>
+        </p:spPr>
+        <p:txBody>
+          <a:bodyPr xmlns:a="http://schemas.openxmlformats.org/drawingml/2006/main" wrap="square" lIns="0" tIns="0" rIns="0" bIns="0" anchor="t">
+            <a:normAutofit fontScale="100000"/>
+          </a:bodyPr>
+          <a:lstStyle xmlns:a="http://schemas.openxmlformats.org/drawingml/2006/main">
+            <a:defPPr algn="l">
+              <a:defRPr sz="1650" b="1">
+                <a:solidFill>
+                  <a:srgbClr val="172821"/>
+                </a:solidFill>
+                <a:latin typeface="Avenir Next"/>
+                <a:ea typeface="Avenir Next"/>
+                <a:cs typeface="Avenir Next"/>
+              </a:defRPr>
+            </a:defPPr>
+          </a:lstStyle>
+          <a:p xmlns:a="http://schemas.openxmlformats.org/drawingml/2006/main">
+            <a:pPr algn="l">
+              <a:lnSpc>
+                <a:spcPct val="106000"/>
+              </a:lnSpc>
+              <a:buNone/>
+              <a:defRPr sz="1650" b="1">
+                <a:solidFill>
+                  <a:srgbClr val="172821"/>
+                </a:solidFill>
+                <a:latin typeface="Avenir Next"/>
+                <a:ea typeface="Avenir Next"/>
+                <a:cs typeface="Avenir Next"/>
+              </a:defRPr>
+            </a:pPr>
+            <a:r>
+              <a:rPr sz="1650" b="1">
+                <a:solidFill>
+                  <a:srgbClr val="172821"/>
+                </a:solidFill>
+                <a:latin typeface="Avenir Next"/>
+                <a:ea typeface="Avenir Next"/>
+                <a:cs typeface="Avenir Next"/>
+              </a:rPr>
+              <a:t>Cloud readiness check</a:t>
+            </a:r>
+          </a:p>
+        </p:txBody>
+      </p:sp>
+      <p:sp>
+        <p:nvSpPr>
+          <p:cNvPr id="21" name="Test persistence and both flows before d">
+            <a:extLst xmlns:a="http://schemas.openxmlformats.org/drawingml/2006/main">
+              <a:ext uri="{FF2B5EF4-FFF2-40B4-BE49-F238E27FC236}">
+                <a16:creationId xmlns:a16="http://schemas.microsoft.com/office/drawing/2014/main" id="{53FCB582-C816-44BB-9B50-1DE72C90BD07}"/>
+              </a:ext>
+            </a:extLst>
+          </p:cNvPr>
+          <p:cNvSpPr>
+            <a:spLocks xmlns:a="http://schemas.openxmlformats.org/drawingml/2006/main" noGrp="1"/>
+          </p:cNvSpPr>
+          <p:nvPr/>
+        </p:nvSpPr>
+        <p:spPr>
+          <a:xfrm xmlns:a="http://schemas.openxmlformats.org/drawingml/2006/main">
+            <a:off x="6686550" y="4362450"/>
+            <a:ext cx="4143375" cy="495300"/>
+          </a:xfrm>
+          <a:prstGeom xmlns:a="http://schemas.openxmlformats.org/drawingml/2006/main" prst="rect">
+            <a:avLst/>
+          </a:prstGeom>
+          <a:noFill xmlns:a="http://schemas.openxmlformats.org/drawingml/2006/main"/>
+          <a:ln xmlns:a="http://schemas.openxmlformats.org/drawingml/2006/main" w="0">
+            <a:noFill/>
+            <a:prstDash val="solid"/>
+          </a:ln>
+        </p:spPr>
+        <p:txBody>
+          <a:bodyPr xmlns:a="http://schemas.openxmlformats.org/drawingml/2006/main" wrap="square" lIns="0" tIns="0" rIns="0" bIns="0" anchor="t">
+            <a:normAutofit fontScale="100000"/>
+          </a:bodyPr>
+          <a:lstStyle xmlns:a="http://schemas.openxmlformats.org/drawingml/2006/main">
+            <a:defPPr algn="l">
+              <a:defRPr sz="1200" b="0">
+                <a:solidFill>
+                  <a:srgbClr val="59675F"/>
+                </a:solidFill>
+                <a:latin typeface="Avenir Next"/>
+                <a:ea typeface="Avenir Next"/>
+                <a:cs typeface="Avenir Next"/>
+              </a:defRPr>
+            </a:defPPr>
+          </a:lstStyle>
+          <a:p xmlns:a="http://schemas.openxmlformats.org/drawingml/2006/main">
+            <a:pPr algn="l">
+              <a:lnSpc>
+                <a:spcPct val="106000"/>
+              </a:lnSpc>
+              <a:buNone/>
+              <a:defRPr sz="1200" b="0">
+                <a:solidFill>
+                  <a:srgbClr val="59675F"/>
+                </a:solidFill>
+                <a:latin typeface="Avenir Next"/>
+                <a:ea typeface="Avenir Next"/>
+                <a:cs typeface="Avenir Next"/>
+              </a:defRPr>
+            </a:pPr>
+            <a:r>
+              <a:rPr sz="1200" b="0">
+                <a:solidFill>
+                  <a:srgbClr val="59675F"/>
+                </a:solidFill>
+                <a:latin typeface="Avenir Next"/>
+                <a:ea typeface="Avenir Next"/>
+                <a:cs typeface="Avenir Next"/>
+              </a:rPr>
+              <a:t>Test persistence and both flows before describing a cloud deployment.</a:t>
+            </a:r>
+          </a:p>
+        </p:txBody>
+      </p:sp>
+      <p:sp>
+        <p:nvSpPr>
+          <p:cNvPr id="22" name="">
+            <a:extLst xmlns:a="http://schemas.openxmlformats.org/drawingml/2006/main">
+              <a:ext uri="{FF2B5EF4-FFF2-40B4-BE49-F238E27FC236}">
+                <a16:creationId xmlns:a16="http://schemas.microsoft.com/office/drawing/2014/main" id="{43B10D6E-D302-446B-B687-62063B2B1FBD}"/>
+              </a:ext>
+            </a:extLst>
+          </p:cNvPr>
+          <p:cNvSpPr>
+            <a:spLocks xmlns:a="http://schemas.openxmlformats.org/drawingml/2006/main" noGrp="1"/>
+          </p:cNvSpPr>
+          <p:nvPr/>
+        </p:nvSpPr>
+        <p:spPr>
+          <a:xfrm xmlns:a="http://schemas.openxmlformats.org/drawingml/2006/main">
+            <a:off x="6686550" y="5067300"/>
+            <a:ext cx="4152900" cy="19050"/>
+          </a:xfrm>
+          <a:prstGeom xmlns:a="http://schemas.openxmlformats.org/drawingml/2006/main" prst="rect">
+            <a:avLst/>
+          </a:prstGeom>
+          <a:solidFill xmlns:a="http://schemas.openxmlformats.org/drawingml/2006/main">
+            <a:srgbClr val="176B4B"/>
+          </a:solidFill>
+          <a:ln xmlns:a="http://schemas.openxmlformats.org/drawingml/2006/main" w="0">
+            <a:noFill/>
+            <a:prstDash val="solid"/>
+          </a:ln>
+        </p:spPr>
+      </p:sp>
+      <p:sp>
+        <p:nvSpPr>
+          <p:cNvPr id="23" name="MVP boundary">
+            <a:extLst xmlns:a="http://schemas.openxmlformats.org/drawingml/2006/main">
+              <a:ext uri="{FF2B5EF4-FFF2-40B4-BE49-F238E27FC236}">
+                <a16:creationId xmlns:a16="http://schemas.microsoft.com/office/drawing/2014/main" id="{5595B7F8-F094-4483-B3E9-1E3B8F06E56A}"/>
+              </a:ext>
+            </a:extLst>
+          </p:cNvPr>
+          <p:cNvSpPr>
+            <a:spLocks xmlns:a="http://schemas.openxmlformats.org/drawingml/2006/main" noGrp="1"/>
+          </p:cNvSpPr>
+          <p:nvPr/>
+        </p:nvSpPr>
+        <p:spPr>
+          <a:xfrm xmlns:a="http://schemas.openxmlformats.org/drawingml/2006/main">
+            <a:off x="6686550" y="5276850"/>
+            <a:ext cx="2381250" cy="247650"/>
+          </a:xfrm>
+          <a:prstGeom xmlns:a="http://schemas.openxmlformats.org/drawingml/2006/main" prst="rect">
+            <a:avLst/>
+          </a:prstGeom>
+          <a:noFill xmlns:a="http://schemas.openxmlformats.org/drawingml/2006/main"/>
+          <a:ln xmlns:a="http://schemas.openxmlformats.org/drawingml/2006/main" w="0">
+            <a:noFill/>
+            <a:prstDash val="solid"/>
+          </a:ln>
+        </p:spPr>
+        <p:txBody>
+          <a:bodyPr xmlns:a="http://schemas.openxmlformats.org/drawingml/2006/main" wrap="square" lIns="0" tIns="0" rIns="0" bIns="0" anchor="t">
+            <a:normAutofit fontScale="100000"/>
+          </a:bodyPr>
+          <a:lstStyle xmlns:a="http://schemas.openxmlformats.org/drawingml/2006/main">
+            <a:defPPr algn="l">
+              <a:defRPr sz="1350" b="1">
+                <a:solidFill>
+                  <a:srgbClr val="176B4B"/>
+                </a:solidFill>
+                <a:latin typeface="Avenir Next"/>
+                <a:ea typeface="Avenir Next"/>
+                <a:cs typeface="Avenir Next"/>
+              </a:defRPr>
+            </a:defPPr>
+          </a:lstStyle>
+          <a:p xmlns:a="http://schemas.openxmlformats.org/drawingml/2006/main">
+            <a:pPr algn="l">
+              <a:lnSpc>
+                <a:spcPct val="106000"/>
+              </a:lnSpc>
+              <a:buNone/>
+              <a:defRPr sz="1350" b="1">
+                <a:solidFill>
+                  <a:srgbClr val="176B4B"/>
+                </a:solidFill>
+                <a:latin typeface="Avenir Next"/>
+                <a:ea typeface="Avenir Next"/>
+                <a:cs typeface="Avenir Next"/>
+              </a:defRPr>
+            </a:pPr>
+            <a:r>
+              <a:rPr sz="1350" b="1">
+                <a:solidFill>
+                  <a:srgbClr val="176B4B"/>
+                </a:solidFill>
+                <a:latin typeface="Avenir Next"/>
+                <a:ea typeface="Avenir Next"/>
+                <a:cs typeface="Avenir Next"/>
+              </a:rPr>
+              <a:t>MVP boundary</a:t>
+            </a:r>
+          </a:p>
+        </p:txBody>
+      </p:sp>
+      <p:sp>
+        <p:nvSpPr>
+          <p:cNvPr id="24" name="Synthetic data. Simulated outcomes. No p">
+            <a:extLst xmlns:a="http://schemas.openxmlformats.org/drawingml/2006/main">
+              <a:ext uri="{FF2B5EF4-FFF2-40B4-BE49-F238E27FC236}">
+                <a16:creationId xmlns:a16="http://schemas.microsoft.com/office/drawing/2014/main" id="{5DDEEB2B-1510-4262-B559-C9BCA240512B}"/>
+              </a:ext>
+            </a:extLst>
+          </p:cNvPr>
+          <p:cNvSpPr>
+            <a:spLocks xmlns:a="http://schemas.openxmlformats.org/drawingml/2006/main" noGrp="1"/>
+          </p:cNvSpPr>
+          <p:nvPr/>
+        </p:nvSpPr>
+        <p:spPr>
+          <a:xfrm xmlns:a="http://schemas.openxmlformats.org/drawingml/2006/main">
+            <a:off x="6686550" y="5638800"/>
+            <a:ext cx="4210050" cy="381000"/>
           </a:xfrm>
           <a:prstGeom xmlns:a="http://schemas.openxmlformats.org/drawingml/2006/main" prst="rect">
             <a:avLst/>
@@ -12533,7 +13134,7 @@
             <a:defPPr algn="l">
               <a:defRPr sz="1125" b="0">
                 <a:solidFill>
-                  <a:srgbClr val="59675F"/>
+                  <a:srgbClr val="172821"/>
                 </a:solidFill>
                 <a:latin typeface="Avenir Next"/>
                 <a:ea typeface="Avenir Next"/>
@@ -12549,607 +13150,6 @@
               <a:buNone/>
               <a:defRPr sz="1125" b="0">
                 <a:solidFill>
-                  <a:srgbClr val="59675F"/>
-                </a:solidFill>
-                <a:latin typeface="Avenir Next"/>
-                <a:ea typeface="Avenir Next"/>
-                <a:cs typeface="Avenir Next"/>
-              </a:defRPr>
-            </a:pPr>
-            <a:r>
-              <a:rPr sz="1125" b="0">
-                <a:solidFill>
-                  <a:srgbClr val="59675F"/>
-                </a:solidFill>
-                <a:latin typeface="Avenir Next"/>
-                <a:ea typeface="Avenir Next"/>
-                <a:cs typeface="Avenir Next"/>
-              </a:rPr>
-              <a:t>Configure Gemini classification and explanation separately; Jev remains optional.</a:t>
-            </a:r>
-          </a:p>
-        </p:txBody>
-      </p:sp>
-      <p:sp>
-        <p:nvSpPr>
-          <p:cNvPr id="15" name="">
-            <a:extLst xmlns:a="http://schemas.openxmlformats.org/drawingml/2006/main">
-              <a:ext uri="{FF2B5EF4-FFF2-40B4-BE49-F238E27FC236}">
-                <a16:creationId xmlns:a16="http://schemas.microsoft.com/office/drawing/2014/main" id="{2F0936EE-9003-4899-8FE2-7C83CEE3CA1D}"/>
-              </a:ext>
-            </a:extLst>
-          </p:cNvPr>
-          <p:cNvSpPr>
-            <a:spLocks xmlns:a="http://schemas.openxmlformats.org/drawingml/2006/main" noGrp="1"/>
-          </p:cNvSpPr>
-          <p:nvPr/>
-        </p:nvSpPr>
-        <p:spPr>
-          <a:xfrm xmlns:a="http://schemas.openxmlformats.org/drawingml/2006/main">
-            <a:off x="6172200" y="2324100"/>
-            <a:ext cx="9525" cy="0"/>
-          </a:xfrm>
-          <a:prstGeom xmlns:a="http://schemas.openxmlformats.org/drawingml/2006/main" prst="rect">
-            <a:avLst/>
-          </a:prstGeom>
-          <a:ln xmlns:a="http://schemas.openxmlformats.org/drawingml/2006/main" w="0">
-            <a:noFill/>
-            <a:prstDash val="solid"/>
-          </a:ln>
-        </p:spPr>
-      </p:sp>
-      <p:sp>
-        <p:nvSpPr>
-          <p:cNvPr id="16" name="NEXT 24 HOURS  /  BUFFER">
-            <a:extLst xmlns:a="http://schemas.openxmlformats.org/drawingml/2006/main">
-              <a:ext uri="{FF2B5EF4-FFF2-40B4-BE49-F238E27FC236}">
-                <a16:creationId xmlns:a16="http://schemas.microsoft.com/office/drawing/2014/main" id="{7046BE3F-22CE-4983-972C-6349D49642A7}"/>
-              </a:ext>
-            </a:extLst>
-          </p:cNvPr>
-          <p:cNvSpPr>
-            <a:spLocks xmlns:a="http://schemas.openxmlformats.org/drawingml/2006/main" noGrp="1"/>
-          </p:cNvSpPr>
-          <p:nvPr/>
-        </p:nvSpPr>
-        <p:spPr>
-          <a:xfrm xmlns:a="http://schemas.openxmlformats.org/drawingml/2006/main">
-            <a:off x="6686550" y="2324100"/>
-            <a:ext cx="3810000" cy="190500"/>
-          </a:xfrm>
-          <a:prstGeom xmlns:a="http://schemas.openxmlformats.org/drawingml/2006/main" prst="rect">
-            <a:avLst/>
-          </a:prstGeom>
-          <a:noFill xmlns:a="http://schemas.openxmlformats.org/drawingml/2006/main"/>
-          <a:ln xmlns:a="http://schemas.openxmlformats.org/drawingml/2006/main" w="0">
-            <a:noFill/>
-            <a:prstDash val="solid"/>
-          </a:ln>
-        </p:spPr>
-        <p:txBody>
-          <a:bodyPr xmlns:a="http://schemas.openxmlformats.org/drawingml/2006/main" wrap="square" lIns="0" tIns="0" rIns="0" bIns="0" anchor="t">
-            <a:normAutofit fontScale="100000"/>
-          </a:bodyPr>
-          <a:lstStyle xmlns:a="http://schemas.openxmlformats.org/drawingml/2006/main">
-            <a:defPPr algn="l">
-              <a:defRPr sz="900" b="1">
-                <a:solidFill>
-                  <a:srgbClr val="BE7839"/>
-                </a:solidFill>
-                <a:latin typeface="Avenir Next"/>
-                <a:ea typeface="Avenir Next"/>
-                <a:cs typeface="Avenir Next"/>
-              </a:defRPr>
-            </a:defPPr>
-          </a:lstStyle>
-          <a:p xmlns:a="http://schemas.openxmlformats.org/drawingml/2006/main">
-            <a:pPr algn="l">
-              <a:lnSpc>
-                <a:spcPct val="106000"/>
-              </a:lnSpc>
-              <a:buNone/>
-              <a:defRPr sz="900" b="1">
-                <a:solidFill>
-                  <a:srgbClr val="BE7839"/>
-                </a:solidFill>
-                <a:latin typeface="Avenir Next"/>
-                <a:ea typeface="Avenir Next"/>
-                <a:cs typeface="Avenir Next"/>
-              </a:defRPr>
-            </a:pPr>
-            <a:r>
-              <a:rPr sz="900" b="1">
-                <a:solidFill>
-                  <a:srgbClr val="BE7839"/>
-                </a:solidFill>
-                <a:latin typeface="Avenir Next"/>
-                <a:ea typeface="Avenir Next"/>
-                <a:cs typeface="Avenir Next"/>
-              </a:rPr>
-              <a:t>NEXT 24 HOURS  /  BUFFER</a:t>
-            </a:r>
-          </a:p>
-        </p:txBody>
-      </p:sp>
-      <p:sp>
-        <p:nvSpPr>
-          <p:cNvPr id="17" name="Held-out evaluation">
-            <a:extLst xmlns:a="http://schemas.openxmlformats.org/drawingml/2006/main">
-              <a:ext uri="{FF2B5EF4-FFF2-40B4-BE49-F238E27FC236}">
-                <a16:creationId xmlns:a16="http://schemas.microsoft.com/office/drawing/2014/main" id="{CAF28D9F-BF0F-45A6-B0C1-4FB98D97815E}"/>
-              </a:ext>
-            </a:extLst>
-          </p:cNvPr>
-          <p:cNvSpPr>
-            <a:spLocks xmlns:a="http://schemas.openxmlformats.org/drawingml/2006/main" noGrp="1"/>
-          </p:cNvSpPr>
-          <p:nvPr/>
-        </p:nvSpPr>
-        <p:spPr>
-          <a:xfrm xmlns:a="http://schemas.openxmlformats.org/drawingml/2006/main">
-            <a:off x="6686550" y="2686050"/>
-            <a:ext cx="4095750" cy="276225"/>
-          </a:xfrm>
-          <a:prstGeom xmlns:a="http://schemas.openxmlformats.org/drawingml/2006/main" prst="rect">
-            <a:avLst/>
-          </a:prstGeom>
-          <a:noFill xmlns:a="http://schemas.openxmlformats.org/drawingml/2006/main"/>
-          <a:ln xmlns:a="http://schemas.openxmlformats.org/drawingml/2006/main" w="0">
-            <a:noFill/>
-            <a:prstDash val="solid"/>
-          </a:ln>
-        </p:spPr>
-        <p:txBody>
-          <a:bodyPr xmlns:a="http://schemas.openxmlformats.org/drawingml/2006/main" wrap="square" lIns="0" tIns="0" rIns="0" bIns="0" anchor="t">
-            <a:normAutofit fontScale="100000"/>
-          </a:bodyPr>
-          <a:lstStyle xmlns:a="http://schemas.openxmlformats.org/drawingml/2006/main">
-            <a:defPPr algn="l">
-              <a:defRPr sz="1650" b="1">
-                <a:solidFill>
-                  <a:srgbClr val="172821"/>
-                </a:solidFill>
-                <a:latin typeface="Avenir Next"/>
-                <a:ea typeface="Avenir Next"/>
-                <a:cs typeface="Avenir Next"/>
-              </a:defRPr>
-            </a:defPPr>
-          </a:lstStyle>
-          <a:p xmlns:a="http://schemas.openxmlformats.org/drawingml/2006/main">
-            <a:pPr algn="l">
-              <a:lnSpc>
-                <a:spcPct val="106000"/>
-              </a:lnSpc>
-              <a:buNone/>
-              <a:defRPr sz="1650" b="1">
-                <a:solidFill>
-                  <a:srgbClr val="172821"/>
-                </a:solidFill>
-                <a:latin typeface="Avenir Next"/>
-                <a:ea typeface="Avenir Next"/>
-                <a:cs typeface="Avenir Next"/>
-              </a:defRPr>
-            </a:pPr>
-            <a:r>
-              <a:rPr sz="1650" b="1">
-                <a:solidFill>
-                  <a:srgbClr val="172821"/>
-                </a:solidFill>
-                <a:latin typeface="Avenir Next"/>
-                <a:ea typeface="Avenir Next"/>
-                <a:cs typeface="Avenir Next"/>
-              </a:rPr>
-              <a:t>Held-out evaluation</a:t>
-            </a:r>
-          </a:p>
-        </p:txBody>
-      </p:sp>
-      <p:sp>
-        <p:nvSpPr>
-          <p:cNvPr id="18" name="Compare policy behavior, record failures">
-            <a:extLst xmlns:a="http://schemas.openxmlformats.org/drawingml/2006/main">
-              <a:ext uri="{FF2B5EF4-FFF2-40B4-BE49-F238E27FC236}">
-                <a16:creationId xmlns:a16="http://schemas.microsoft.com/office/drawing/2014/main" id="{D918D7BA-25D3-4425-8579-8A7C85999E4B}"/>
-              </a:ext>
-            </a:extLst>
-          </p:cNvPr>
-          <p:cNvSpPr>
-            <a:spLocks xmlns:a="http://schemas.openxmlformats.org/drawingml/2006/main" noGrp="1"/>
-          </p:cNvSpPr>
-          <p:nvPr/>
-        </p:nvSpPr>
-        <p:spPr>
-          <a:xfrm xmlns:a="http://schemas.openxmlformats.org/drawingml/2006/main">
-            <a:off x="6686550" y="3067050"/>
-            <a:ext cx="4133850" cy="495300"/>
-          </a:xfrm>
-          <a:prstGeom xmlns:a="http://schemas.openxmlformats.org/drawingml/2006/main" prst="rect">
-            <a:avLst/>
-          </a:prstGeom>
-          <a:noFill xmlns:a="http://schemas.openxmlformats.org/drawingml/2006/main"/>
-          <a:ln xmlns:a="http://schemas.openxmlformats.org/drawingml/2006/main" w="0">
-            <a:noFill/>
-            <a:prstDash val="solid"/>
-          </a:ln>
-        </p:spPr>
-        <p:txBody>
-          <a:bodyPr xmlns:a="http://schemas.openxmlformats.org/drawingml/2006/main" wrap="square" lIns="0" tIns="0" rIns="0" bIns="0" anchor="t">
-            <a:normAutofit fontScale="100000"/>
-          </a:bodyPr>
-          <a:lstStyle xmlns:a="http://schemas.openxmlformats.org/drawingml/2006/main">
-            <a:defPPr algn="l">
-              <a:defRPr sz="1200" b="0">
-                <a:solidFill>
-                  <a:srgbClr val="59675F"/>
-                </a:solidFill>
-                <a:latin typeface="Avenir Next"/>
-                <a:ea typeface="Avenir Next"/>
-                <a:cs typeface="Avenir Next"/>
-              </a:defRPr>
-            </a:defPPr>
-          </a:lstStyle>
-          <a:p xmlns:a="http://schemas.openxmlformats.org/drawingml/2006/main">
-            <a:pPr algn="l">
-              <a:lnSpc>
-                <a:spcPct val="106000"/>
-              </a:lnSpc>
-              <a:buNone/>
-              <a:defRPr sz="1200" b="0">
-                <a:solidFill>
-                  <a:srgbClr val="59675F"/>
-                </a:solidFill>
-                <a:latin typeface="Avenir Next"/>
-                <a:ea typeface="Avenir Next"/>
-                <a:cs typeface="Avenir Next"/>
-              </a:defRPr>
-            </a:pPr>
-            <a:r>
-              <a:rPr sz="1200" b="0">
-                <a:solidFill>
-                  <a:srgbClr val="59675F"/>
-                </a:solidFill>
-                <a:latin typeface="Avenir Next"/>
-                <a:ea typeface="Avenir Next"/>
-                <a:cs typeface="Avenir Next"/>
-              </a:rPr>
-              <a:t>Compare policy behavior, record failures and measure latency by stage.</a:t>
-            </a:r>
-          </a:p>
-        </p:txBody>
-      </p:sp>
-      <p:sp>
-        <p:nvSpPr>
-          <p:cNvPr id="19" name="">
-            <a:extLst xmlns:a="http://schemas.openxmlformats.org/drawingml/2006/main">
-              <a:ext uri="{FF2B5EF4-FFF2-40B4-BE49-F238E27FC236}">
-                <a16:creationId xmlns:a16="http://schemas.microsoft.com/office/drawing/2014/main" id="{9EC1DE98-3551-4E6B-8B61-AD10C361CDC8}"/>
-              </a:ext>
-            </a:extLst>
-          </p:cNvPr>
-          <p:cNvSpPr>
-            <a:spLocks xmlns:a="http://schemas.openxmlformats.org/drawingml/2006/main" noGrp="1"/>
-          </p:cNvSpPr>
-          <p:nvPr/>
-        </p:nvSpPr>
-        <p:spPr>
-          <a:xfrm xmlns:a="http://schemas.openxmlformats.org/drawingml/2006/main">
-            <a:off x="6686550" y="3771900"/>
-            <a:ext cx="4152900" cy="9525"/>
-          </a:xfrm>
-          <a:prstGeom xmlns:a="http://schemas.openxmlformats.org/drawingml/2006/main" prst="rect">
-            <a:avLst/>
-          </a:prstGeom>
-          <a:solidFill xmlns:a="http://schemas.openxmlformats.org/drawingml/2006/main">
-            <a:srgbClr val="C9D1C8"/>
-          </a:solidFill>
-          <a:ln xmlns:a="http://schemas.openxmlformats.org/drawingml/2006/main" w="0">
-            <a:noFill/>
-            <a:prstDash val="solid"/>
-          </a:ln>
-        </p:spPr>
-      </p:sp>
-      <p:sp>
-        <p:nvSpPr>
-          <p:cNvPr id="20" name="Cloud readiness check">
-            <a:extLst xmlns:a="http://schemas.openxmlformats.org/drawingml/2006/main">
-              <a:ext uri="{FF2B5EF4-FFF2-40B4-BE49-F238E27FC236}">
-                <a16:creationId xmlns:a16="http://schemas.microsoft.com/office/drawing/2014/main" id="{4FAA1678-0A92-4937-A133-F485561DDAE2}"/>
-              </a:ext>
-            </a:extLst>
-          </p:cNvPr>
-          <p:cNvSpPr>
-            <a:spLocks xmlns:a="http://schemas.openxmlformats.org/drawingml/2006/main" noGrp="1"/>
-          </p:cNvSpPr>
-          <p:nvPr/>
-        </p:nvSpPr>
-        <p:spPr>
-          <a:xfrm xmlns:a="http://schemas.openxmlformats.org/drawingml/2006/main">
-            <a:off x="6686550" y="3981450"/>
-            <a:ext cx="4095750" cy="276225"/>
-          </a:xfrm>
-          <a:prstGeom xmlns:a="http://schemas.openxmlformats.org/drawingml/2006/main" prst="rect">
-            <a:avLst/>
-          </a:prstGeom>
-          <a:noFill xmlns:a="http://schemas.openxmlformats.org/drawingml/2006/main"/>
-          <a:ln xmlns:a="http://schemas.openxmlformats.org/drawingml/2006/main" w="0">
-            <a:noFill/>
-            <a:prstDash val="solid"/>
-          </a:ln>
-        </p:spPr>
-        <p:txBody>
-          <a:bodyPr xmlns:a="http://schemas.openxmlformats.org/drawingml/2006/main" wrap="square" lIns="0" tIns="0" rIns="0" bIns="0" anchor="t">
-            <a:normAutofit fontScale="100000"/>
-          </a:bodyPr>
-          <a:lstStyle xmlns:a="http://schemas.openxmlformats.org/drawingml/2006/main">
-            <a:defPPr algn="l">
-              <a:defRPr sz="1650" b="1">
-                <a:solidFill>
-                  <a:srgbClr val="172821"/>
-                </a:solidFill>
-                <a:latin typeface="Avenir Next"/>
-                <a:ea typeface="Avenir Next"/>
-                <a:cs typeface="Avenir Next"/>
-              </a:defRPr>
-            </a:defPPr>
-          </a:lstStyle>
-          <a:p xmlns:a="http://schemas.openxmlformats.org/drawingml/2006/main">
-            <a:pPr algn="l">
-              <a:lnSpc>
-                <a:spcPct val="106000"/>
-              </a:lnSpc>
-              <a:buNone/>
-              <a:defRPr sz="1650" b="1">
-                <a:solidFill>
-                  <a:srgbClr val="172821"/>
-                </a:solidFill>
-                <a:latin typeface="Avenir Next"/>
-                <a:ea typeface="Avenir Next"/>
-                <a:cs typeface="Avenir Next"/>
-              </a:defRPr>
-            </a:pPr>
-            <a:r>
-              <a:rPr sz="1650" b="1">
-                <a:solidFill>
-                  <a:srgbClr val="172821"/>
-                </a:solidFill>
-                <a:latin typeface="Avenir Next"/>
-                <a:ea typeface="Avenir Next"/>
-                <a:cs typeface="Avenir Next"/>
-              </a:rPr>
-              <a:t>Cloud readiness check</a:t>
-            </a:r>
-          </a:p>
-        </p:txBody>
-      </p:sp>
-      <p:sp>
-        <p:nvSpPr>
-          <p:cNvPr id="21" name="Test persistence and both flows before d">
-            <a:extLst xmlns:a="http://schemas.openxmlformats.org/drawingml/2006/main">
-              <a:ext uri="{FF2B5EF4-FFF2-40B4-BE49-F238E27FC236}">
-                <a16:creationId xmlns:a16="http://schemas.microsoft.com/office/drawing/2014/main" id="{3951E480-4AE7-44A7-9EE2-97BED5D3759D}"/>
-              </a:ext>
-            </a:extLst>
-          </p:cNvPr>
-          <p:cNvSpPr>
-            <a:spLocks xmlns:a="http://schemas.openxmlformats.org/drawingml/2006/main" noGrp="1"/>
-          </p:cNvSpPr>
-          <p:nvPr/>
-        </p:nvSpPr>
-        <p:spPr>
-          <a:xfrm xmlns:a="http://schemas.openxmlformats.org/drawingml/2006/main">
-            <a:off x="6686550" y="4362450"/>
-            <a:ext cx="4143375" cy="495300"/>
-          </a:xfrm>
-          <a:prstGeom xmlns:a="http://schemas.openxmlformats.org/drawingml/2006/main" prst="rect">
-            <a:avLst/>
-          </a:prstGeom>
-          <a:noFill xmlns:a="http://schemas.openxmlformats.org/drawingml/2006/main"/>
-          <a:ln xmlns:a="http://schemas.openxmlformats.org/drawingml/2006/main" w="0">
-            <a:noFill/>
-            <a:prstDash val="solid"/>
-          </a:ln>
-        </p:spPr>
-        <p:txBody>
-          <a:bodyPr xmlns:a="http://schemas.openxmlformats.org/drawingml/2006/main" wrap="square" lIns="0" tIns="0" rIns="0" bIns="0" anchor="t">
-            <a:normAutofit fontScale="100000"/>
-          </a:bodyPr>
-          <a:lstStyle xmlns:a="http://schemas.openxmlformats.org/drawingml/2006/main">
-            <a:defPPr algn="l">
-              <a:defRPr sz="1200" b="0">
-                <a:solidFill>
-                  <a:srgbClr val="59675F"/>
-                </a:solidFill>
-                <a:latin typeface="Avenir Next"/>
-                <a:ea typeface="Avenir Next"/>
-                <a:cs typeface="Avenir Next"/>
-              </a:defRPr>
-            </a:defPPr>
-          </a:lstStyle>
-          <a:p xmlns:a="http://schemas.openxmlformats.org/drawingml/2006/main">
-            <a:pPr algn="l">
-              <a:lnSpc>
-                <a:spcPct val="106000"/>
-              </a:lnSpc>
-              <a:buNone/>
-              <a:defRPr sz="1200" b="0">
-                <a:solidFill>
-                  <a:srgbClr val="59675F"/>
-                </a:solidFill>
-                <a:latin typeface="Avenir Next"/>
-                <a:ea typeface="Avenir Next"/>
-                <a:cs typeface="Avenir Next"/>
-              </a:defRPr>
-            </a:pPr>
-            <a:r>
-              <a:rPr sz="1200" b="0">
-                <a:solidFill>
-                  <a:srgbClr val="59675F"/>
-                </a:solidFill>
-                <a:latin typeface="Avenir Next"/>
-                <a:ea typeface="Avenir Next"/>
-                <a:cs typeface="Avenir Next"/>
-              </a:rPr>
-              <a:t>Test persistence and both flows before describing a cloud deployment.</a:t>
-            </a:r>
-          </a:p>
-        </p:txBody>
-      </p:sp>
-      <p:sp>
-        <p:nvSpPr>
-          <p:cNvPr id="22" name="">
-            <a:extLst xmlns:a="http://schemas.openxmlformats.org/drawingml/2006/main">
-              <a:ext uri="{FF2B5EF4-FFF2-40B4-BE49-F238E27FC236}">
-                <a16:creationId xmlns:a16="http://schemas.microsoft.com/office/drawing/2014/main" id="{0F8A4702-E516-4168-A0C0-0B0E03EE954B}"/>
-              </a:ext>
-            </a:extLst>
-          </p:cNvPr>
-          <p:cNvSpPr>
-            <a:spLocks xmlns:a="http://schemas.openxmlformats.org/drawingml/2006/main" noGrp="1"/>
-          </p:cNvSpPr>
-          <p:nvPr/>
-        </p:nvSpPr>
-        <p:spPr>
-          <a:xfrm xmlns:a="http://schemas.openxmlformats.org/drawingml/2006/main">
-            <a:off x="6686550" y="5067300"/>
-            <a:ext cx="4152900" cy="19050"/>
-          </a:xfrm>
-          <a:prstGeom xmlns:a="http://schemas.openxmlformats.org/drawingml/2006/main" prst="rect">
-            <a:avLst/>
-          </a:prstGeom>
-          <a:solidFill xmlns:a="http://schemas.openxmlformats.org/drawingml/2006/main">
-            <a:srgbClr val="176B4B"/>
-          </a:solidFill>
-          <a:ln xmlns:a="http://schemas.openxmlformats.org/drawingml/2006/main" w="0">
-            <a:noFill/>
-            <a:prstDash val="solid"/>
-          </a:ln>
-        </p:spPr>
-      </p:sp>
-      <p:sp>
-        <p:nvSpPr>
-          <p:cNvPr id="23" name="MVP boundary">
-            <a:extLst xmlns:a="http://schemas.openxmlformats.org/drawingml/2006/main">
-              <a:ext uri="{FF2B5EF4-FFF2-40B4-BE49-F238E27FC236}">
-                <a16:creationId xmlns:a16="http://schemas.microsoft.com/office/drawing/2014/main" id="{1C34525E-AA80-4474-8604-BAB97AE46A5A}"/>
-              </a:ext>
-            </a:extLst>
-          </p:cNvPr>
-          <p:cNvSpPr>
-            <a:spLocks xmlns:a="http://schemas.openxmlformats.org/drawingml/2006/main" noGrp="1"/>
-          </p:cNvSpPr>
-          <p:nvPr/>
-        </p:nvSpPr>
-        <p:spPr>
-          <a:xfrm xmlns:a="http://schemas.openxmlformats.org/drawingml/2006/main">
-            <a:off x="6686550" y="5276850"/>
-            <a:ext cx="2381250" cy="247650"/>
-          </a:xfrm>
-          <a:prstGeom xmlns:a="http://schemas.openxmlformats.org/drawingml/2006/main" prst="rect">
-            <a:avLst/>
-          </a:prstGeom>
-          <a:noFill xmlns:a="http://schemas.openxmlformats.org/drawingml/2006/main"/>
-          <a:ln xmlns:a="http://schemas.openxmlformats.org/drawingml/2006/main" w="0">
-            <a:noFill/>
-            <a:prstDash val="solid"/>
-          </a:ln>
-        </p:spPr>
-        <p:txBody>
-          <a:bodyPr xmlns:a="http://schemas.openxmlformats.org/drawingml/2006/main" wrap="square" lIns="0" tIns="0" rIns="0" bIns="0" anchor="t">
-            <a:normAutofit fontScale="100000"/>
-          </a:bodyPr>
-          <a:lstStyle xmlns:a="http://schemas.openxmlformats.org/drawingml/2006/main">
-            <a:defPPr algn="l">
-              <a:defRPr sz="1350" b="1">
-                <a:solidFill>
-                  <a:srgbClr val="176B4B"/>
-                </a:solidFill>
-                <a:latin typeface="Avenir Next"/>
-                <a:ea typeface="Avenir Next"/>
-                <a:cs typeface="Avenir Next"/>
-              </a:defRPr>
-            </a:defPPr>
-          </a:lstStyle>
-          <a:p xmlns:a="http://schemas.openxmlformats.org/drawingml/2006/main">
-            <a:pPr algn="l">
-              <a:lnSpc>
-                <a:spcPct val="106000"/>
-              </a:lnSpc>
-              <a:buNone/>
-              <a:defRPr sz="1350" b="1">
-                <a:solidFill>
-                  <a:srgbClr val="176B4B"/>
-                </a:solidFill>
-                <a:latin typeface="Avenir Next"/>
-                <a:ea typeface="Avenir Next"/>
-                <a:cs typeface="Avenir Next"/>
-              </a:defRPr>
-            </a:pPr>
-            <a:r>
-              <a:rPr sz="1350" b="1">
-                <a:solidFill>
-                  <a:srgbClr val="176B4B"/>
-                </a:solidFill>
-                <a:latin typeface="Avenir Next"/>
-                <a:ea typeface="Avenir Next"/>
-                <a:cs typeface="Avenir Next"/>
-              </a:rPr>
-              <a:t>MVP boundary</a:t>
-            </a:r>
-          </a:p>
-        </p:txBody>
-      </p:sp>
-      <p:sp>
-        <p:nvSpPr>
-          <p:cNvPr id="24" name="Synthetic data. Simulated outcomes. No p">
-            <a:extLst xmlns:a="http://schemas.openxmlformats.org/drawingml/2006/main">
-              <a:ext uri="{FF2B5EF4-FFF2-40B4-BE49-F238E27FC236}">
-                <a16:creationId xmlns:a16="http://schemas.microsoft.com/office/drawing/2014/main" id="{CF7EE32E-56BF-4FA1-A733-60BE9E584588}"/>
-              </a:ext>
-            </a:extLst>
-          </p:cNvPr>
-          <p:cNvSpPr>
-            <a:spLocks xmlns:a="http://schemas.openxmlformats.org/drawingml/2006/main" noGrp="1"/>
-          </p:cNvSpPr>
-          <p:nvPr/>
-        </p:nvSpPr>
-        <p:spPr>
-          <a:xfrm xmlns:a="http://schemas.openxmlformats.org/drawingml/2006/main">
-            <a:off x="6686550" y="5638800"/>
-            <a:ext cx="4210050" cy="381000"/>
-          </a:xfrm>
-          <a:prstGeom xmlns:a="http://schemas.openxmlformats.org/drawingml/2006/main" prst="rect">
-            <a:avLst/>
-          </a:prstGeom>
-          <a:noFill xmlns:a="http://schemas.openxmlformats.org/drawingml/2006/main"/>
-          <a:ln xmlns:a="http://schemas.openxmlformats.org/drawingml/2006/main" w="0">
-            <a:noFill/>
-            <a:prstDash val="solid"/>
-          </a:ln>
-        </p:spPr>
-        <p:txBody>
-          <a:bodyPr xmlns:a="http://schemas.openxmlformats.org/drawingml/2006/main" wrap="square" lIns="0" tIns="0" rIns="0" bIns="0" anchor="t">
-            <a:normAutofit fontScale="100000"/>
-          </a:bodyPr>
-          <a:lstStyle xmlns:a="http://schemas.openxmlformats.org/drawingml/2006/main">
-            <a:defPPr algn="l">
-              <a:defRPr sz="1125" b="0">
-                <a:solidFill>
-                  <a:srgbClr val="172821"/>
-                </a:solidFill>
-                <a:latin typeface="Avenir Next"/>
-                <a:ea typeface="Avenir Next"/>
-                <a:cs typeface="Avenir Next"/>
-              </a:defRPr>
-            </a:defPPr>
-          </a:lstStyle>
-          <a:p xmlns:a="http://schemas.openxmlformats.org/drawingml/2006/main">
-            <a:pPr algn="l">
-              <a:lnSpc>
-                <a:spcPct val="106000"/>
-              </a:lnSpc>
-              <a:buNone/>
-              <a:defRPr sz="1125" b="0">
-                <a:solidFill>
                   <a:srgbClr val="172821"/>
                 </a:solidFill>
                 <a:latin typeface="Avenir Next"/>
@@ -13176,7 +13176,7 @@
           <p:cNvPr id="25" name="">
             <a:extLst xmlns:a="http://schemas.openxmlformats.org/drawingml/2006/main">
               <a:ext uri="{FF2B5EF4-FFF2-40B4-BE49-F238E27FC236}">
-                <a16:creationId xmlns:a16="http://schemas.microsoft.com/office/drawing/2014/main" id="{90D878EE-3BF0-455A-85FB-FEC642124364}"/>
+                <a16:creationId xmlns:a16="http://schemas.microsoft.com/office/drawing/2014/main" id="{A1791610-507C-4403-937F-D86CF8F4F40F}"/>
               </a:ext>
             </a:extLst>
           </p:cNvPr>
@@ -13204,10 +13204,10 @@
       </p:sp>
       <p:sp>
         <p:nvSpPr>
-          <p:cNvPr id="26" name="Next step: confirm provider access and b">
-            <a:extLst xmlns:a="http://schemas.openxmlformats.org/drawingml/2006/main">
-              <a:ext uri="{FF2B5EF4-FFF2-40B4-BE49-F238E27FC236}">
-                <a16:creationId xmlns:a16="http://schemas.microsoft.com/office/drawing/2014/main" id="{40DF2234-2952-4132-9571-58D028511F2D}"/>
+          <p:cNvPr id="26" name="No paid services provisioned  /  Vertex ">
+            <a:extLst xmlns:a="http://schemas.openxmlformats.org/drawingml/2006/main">
+              <a:ext uri="{FF2B5EF4-FFF2-40B4-BE49-F238E27FC236}">
+                <a16:creationId xmlns:a16="http://schemas.microsoft.com/office/drawing/2014/main" id="{D3C203DA-41A7-4B6D-A728-5C8AE2BABE78}"/>
               </a:ext>
             </a:extLst>
           </p:cNvPr>
@@ -13270,7 +13270,7 @@
                 <a:ea typeface="Avenir Next"/>
                 <a:cs typeface="Avenir Next"/>
               </a:rPr>
-              <a:t>Next step: confirm provider access and begin with fixtures  /  Live integrations remain unverified</a:t>
+              <a:t>No paid services provisioned  /  Vertex and Cloud Run optional; usage can incur charges</a:t>
             </a:r>
           </a:p>
         </p:txBody>
@@ -13278,7 +13278,7 @@
     </p:spTree>
     <p:extLst>
       <p:ext uri="{BB962C8B-B14F-4D97-AF65-F5344CB8AC3E}">
-        <p14:creationId xmlns:p14="http://schemas.microsoft.com/office/powerpoint/2010/main" val="432526913"/>
+        <p14:creationId xmlns:p14="http://schemas.microsoft.com/office/powerpoint/2010/main" val="984526313"/>
       </p:ext>
     </p:extLst>
   </p:cSld>

</xml_diff>